<commit_message>
Update Milestone 2 slides and add PDF export
Co-Authored-By: Claude Sonnet 4.6 <noreply@anthropic.com>
</commit_message>
<xml_diff>
--- a/Milestone2.pptx
+++ b/Milestone2.pptx
@@ -4,8 +4,11 @@
   <p:sldMasterIdLst>
     <p:sldMasterId id="2147483648" r:id="rId1"/>
   </p:sldMasterIdLst>
+  <p:notesMasterIdLst>
+    <p:notesMasterId r:id="rId11"/>
+  </p:notesMasterIdLst>
   <p:sldIdLst>
-    <p:sldId id="256" r:id="rId2"/>
+    <p:sldId id="265" r:id="rId2"/>
     <p:sldId id="257" r:id="rId3"/>
     <p:sldId id="258" r:id="rId4"/>
     <p:sldId id="259" r:id="rId5"/>
@@ -129,6 +132,355 @@
     </p:ext>
   </p:extLst>
 </p:presentation>
+</file>
+
+<file path=ppt/notesMasters/notesMaster1.xml><?xml version="1.0" encoding="utf-8"?>
+<p:notesMaster xmlns:a="http://schemas.openxmlformats.org/drawingml/2006/main" xmlns:r="http://schemas.openxmlformats.org/officeDocument/2006/relationships" xmlns:p="http://schemas.openxmlformats.org/presentationml/2006/main">
+  <p:cSld>
+    <p:bg>
+      <p:bgRef idx="1001">
+        <a:schemeClr val="bg1"/>
+      </p:bgRef>
+    </p:bg>
+    <p:spTree>
+      <p:nvGrpSpPr>
+        <p:cNvPr id="1" name=""/>
+        <p:cNvGrpSpPr/>
+        <p:nvPr/>
+      </p:nvGrpSpPr>
+      <p:grpSpPr>
+        <a:xfrm>
+          <a:off x="0" y="0"/>
+          <a:ext cx="0" cy="0"/>
+          <a:chOff x="0" y="0"/>
+          <a:chExt cx="0" cy="0"/>
+        </a:xfrm>
+      </p:grpSpPr>
+      <p:sp>
+        <p:nvSpPr>
+          <p:cNvPr id="2" name="Header Placeholder 1"/>
+          <p:cNvSpPr>
+            <a:spLocks noGrp="1"/>
+          </p:cNvSpPr>
+          <p:nvPr>
+            <p:ph type="hdr" sz="quarter"/>
+          </p:nvPr>
+        </p:nvSpPr>
+        <p:spPr>
+          <a:xfrm>
+            <a:off x="0" y="0"/>
+            <a:ext cx="2971800" cy="458788"/>
+          </a:xfrm>
+          <a:prstGeom prst="rect">
+            <a:avLst/>
+          </a:prstGeom>
+        </p:spPr>
+        <p:txBody>
+          <a:bodyPr vert="horz" lIns="91440" tIns="45720" rIns="91440" bIns="45720" rtlCol="0"/>
+          <a:lstStyle>
+            <a:lvl1pPr algn="l">
+              <a:defRPr sz="1200"/>
+            </a:lvl1pPr>
+          </a:lstStyle>
+          <a:p>
+            <a:endParaRPr lang="en-US"/>
+          </a:p>
+        </p:txBody>
+      </p:sp>
+      <p:sp>
+        <p:nvSpPr>
+          <p:cNvPr id="3" name="Date Placeholder 2"/>
+          <p:cNvSpPr>
+            <a:spLocks noGrp="1"/>
+          </p:cNvSpPr>
+          <p:nvPr>
+            <p:ph type="dt" idx="1"/>
+          </p:nvPr>
+        </p:nvSpPr>
+        <p:spPr>
+          <a:xfrm>
+            <a:off x="3884613" y="0"/>
+            <a:ext cx="2971800" cy="458788"/>
+          </a:xfrm>
+          <a:prstGeom prst="rect">
+            <a:avLst/>
+          </a:prstGeom>
+        </p:spPr>
+        <p:txBody>
+          <a:bodyPr vert="horz" lIns="91440" tIns="45720" rIns="91440" bIns="45720" rtlCol="0"/>
+          <a:lstStyle>
+            <a:lvl1pPr algn="r">
+              <a:defRPr sz="1200"/>
+            </a:lvl1pPr>
+          </a:lstStyle>
+          <a:p>
+            <a:fld id="{C68C77A4-8137-C54C-8773-4DB14305E73B}" type="datetimeFigureOut">
+              <a:rPr lang="en-US" smtClean="0"/>
+              <a:t>4/11/26</a:t>
+            </a:fld>
+            <a:endParaRPr lang="en-US"/>
+          </a:p>
+        </p:txBody>
+      </p:sp>
+      <p:sp>
+        <p:nvSpPr>
+          <p:cNvPr id="4" name="Slide Image Placeholder 3"/>
+          <p:cNvSpPr>
+            <a:spLocks noGrp="1" noRot="1" noChangeAspect="1"/>
+          </p:cNvSpPr>
+          <p:nvPr>
+            <p:ph type="sldImg" idx="2"/>
+          </p:nvPr>
+        </p:nvSpPr>
+        <p:spPr>
+          <a:xfrm>
+            <a:off x="685800" y="1143000"/>
+            <a:ext cx="5486400" cy="3086100"/>
+          </a:xfrm>
+          <a:prstGeom prst="rect">
+            <a:avLst/>
+          </a:prstGeom>
+          <a:noFill/>
+          <a:ln w="12700">
+            <a:solidFill>
+              <a:prstClr val="black"/>
+            </a:solidFill>
+          </a:ln>
+        </p:spPr>
+        <p:txBody>
+          <a:bodyPr vert="horz" lIns="91440" tIns="45720" rIns="91440" bIns="45720" rtlCol="0" anchor="ctr"/>
+          <a:lstStyle/>
+          <a:p>
+            <a:endParaRPr lang="en-US"/>
+          </a:p>
+        </p:txBody>
+      </p:sp>
+      <p:sp>
+        <p:nvSpPr>
+          <p:cNvPr id="5" name="Notes Placeholder 4"/>
+          <p:cNvSpPr>
+            <a:spLocks noGrp="1"/>
+          </p:cNvSpPr>
+          <p:nvPr>
+            <p:ph type="body" sz="quarter" idx="3"/>
+          </p:nvPr>
+        </p:nvSpPr>
+        <p:spPr>
+          <a:xfrm>
+            <a:off x="685800" y="4400550"/>
+            <a:ext cx="5486400" cy="3600450"/>
+          </a:xfrm>
+          <a:prstGeom prst="rect">
+            <a:avLst/>
+          </a:prstGeom>
+        </p:spPr>
+        <p:txBody>
+          <a:bodyPr vert="horz" lIns="91440" tIns="45720" rIns="91440" bIns="45720" rtlCol="0"/>
+          <a:lstStyle/>
+          <a:p>
+            <a:pPr lvl="0"/>
+            <a:r>
+              <a:rPr lang="en-US"/>
+              <a:t>Click to edit Master text styles</a:t>
+            </a:r>
+          </a:p>
+          <a:p>
+            <a:pPr lvl="1"/>
+            <a:r>
+              <a:rPr lang="en-US"/>
+              <a:t>Second level</a:t>
+            </a:r>
+          </a:p>
+          <a:p>
+            <a:pPr lvl="2"/>
+            <a:r>
+              <a:rPr lang="en-US"/>
+              <a:t>Third level</a:t>
+            </a:r>
+          </a:p>
+          <a:p>
+            <a:pPr lvl="3"/>
+            <a:r>
+              <a:rPr lang="en-US"/>
+              <a:t>Fourth level</a:t>
+            </a:r>
+          </a:p>
+          <a:p>
+            <a:pPr lvl="4"/>
+            <a:r>
+              <a:rPr lang="en-US"/>
+              <a:t>Fifth level</a:t>
+            </a:r>
+          </a:p>
+        </p:txBody>
+      </p:sp>
+      <p:sp>
+        <p:nvSpPr>
+          <p:cNvPr id="6" name="Footer Placeholder 5"/>
+          <p:cNvSpPr>
+            <a:spLocks noGrp="1"/>
+          </p:cNvSpPr>
+          <p:nvPr>
+            <p:ph type="ftr" sz="quarter" idx="4"/>
+          </p:nvPr>
+        </p:nvSpPr>
+        <p:spPr>
+          <a:xfrm>
+            <a:off x="0" y="8685213"/>
+            <a:ext cx="2971800" cy="458787"/>
+          </a:xfrm>
+          <a:prstGeom prst="rect">
+            <a:avLst/>
+          </a:prstGeom>
+        </p:spPr>
+        <p:txBody>
+          <a:bodyPr vert="horz" lIns="91440" tIns="45720" rIns="91440" bIns="45720" rtlCol="0" anchor="b"/>
+          <a:lstStyle>
+            <a:lvl1pPr algn="l">
+              <a:defRPr sz="1200"/>
+            </a:lvl1pPr>
+          </a:lstStyle>
+          <a:p>
+            <a:endParaRPr lang="en-US"/>
+          </a:p>
+        </p:txBody>
+      </p:sp>
+      <p:sp>
+        <p:nvSpPr>
+          <p:cNvPr id="7" name="Slide Number Placeholder 6"/>
+          <p:cNvSpPr>
+            <a:spLocks noGrp="1"/>
+          </p:cNvSpPr>
+          <p:nvPr>
+            <p:ph type="sldNum" sz="quarter" idx="5"/>
+          </p:nvPr>
+        </p:nvSpPr>
+        <p:spPr>
+          <a:xfrm>
+            <a:off x="3884613" y="8685213"/>
+            <a:ext cx="2971800" cy="458787"/>
+          </a:xfrm>
+          <a:prstGeom prst="rect">
+            <a:avLst/>
+          </a:prstGeom>
+        </p:spPr>
+        <p:txBody>
+          <a:bodyPr vert="horz" lIns="91440" tIns="45720" rIns="91440" bIns="45720" rtlCol="0" anchor="b"/>
+          <a:lstStyle>
+            <a:lvl1pPr algn="r">
+              <a:defRPr sz="1200"/>
+            </a:lvl1pPr>
+          </a:lstStyle>
+          <a:p>
+            <a:fld id="{F58AFFA3-7554-8C40-8A09-D2CFAEA68ECB}" type="slidenum">
+              <a:rPr lang="en-US" smtClean="0"/>
+              <a:t>‹#›</a:t>
+            </a:fld>
+            <a:endParaRPr lang="en-US"/>
+          </a:p>
+        </p:txBody>
+      </p:sp>
+    </p:spTree>
+    <p:extLst>
+      <p:ext uri="{BB962C8B-B14F-4D97-AF65-F5344CB8AC3E}">
+        <p14:creationId xmlns:p14="http://schemas.microsoft.com/office/powerpoint/2010/main" val="3327682082"/>
+      </p:ext>
+    </p:extLst>
+  </p:cSld>
+  <p:clrMap bg1="lt1" tx1="dk1" bg2="lt2" tx2="dk2" accent1="accent1" accent2="accent2" accent3="accent3" accent4="accent4" accent5="accent5" accent6="accent6" hlink="hlink" folHlink="folHlink"/>
+  <p:notesStyle>
+    <a:lvl1pPr marL="0" algn="l" defTabSz="914400" rtl="0" eaLnBrk="1" latinLnBrk="0" hangingPunct="1">
+      <a:defRPr sz="1200" kern="1200">
+        <a:solidFill>
+          <a:schemeClr val="tx1"/>
+        </a:solidFill>
+        <a:latin typeface="+mn-lt"/>
+        <a:ea typeface="+mn-ea"/>
+        <a:cs typeface="+mn-cs"/>
+      </a:defRPr>
+    </a:lvl1pPr>
+    <a:lvl2pPr marL="457200" algn="l" defTabSz="914400" rtl="0" eaLnBrk="1" latinLnBrk="0" hangingPunct="1">
+      <a:defRPr sz="1200" kern="1200">
+        <a:solidFill>
+          <a:schemeClr val="tx1"/>
+        </a:solidFill>
+        <a:latin typeface="+mn-lt"/>
+        <a:ea typeface="+mn-ea"/>
+        <a:cs typeface="+mn-cs"/>
+      </a:defRPr>
+    </a:lvl2pPr>
+    <a:lvl3pPr marL="914400" algn="l" defTabSz="914400" rtl="0" eaLnBrk="1" latinLnBrk="0" hangingPunct="1">
+      <a:defRPr sz="1200" kern="1200">
+        <a:solidFill>
+          <a:schemeClr val="tx1"/>
+        </a:solidFill>
+        <a:latin typeface="+mn-lt"/>
+        <a:ea typeface="+mn-ea"/>
+        <a:cs typeface="+mn-cs"/>
+      </a:defRPr>
+    </a:lvl3pPr>
+    <a:lvl4pPr marL="1371600" algn="l" defTabSz="914400" rtl="0" eaLnBrk="1" latinLnBrk="0" hangingPunct="1">
+      <a:defRPr sz="1200" kern="1200">
+        <a:solidFill>
+          <a:schemeClr val="tx1"/>
+        </a:solidFill>
+        <a:latin typeface="+mn-lt"/>
+        <a:ea typeface="+mn-ea"/>
+        <a:cs typeface="+mn-cs"/>
+      </a:defRPr>
+    </a:lvl4pPr>
+    <a:lvl5pPr marL="1828800" algn="l" defTabSz="914400" rtl="0" eaLnBrk="1" latinLnBrk="0" hangingPunct="1">
+      <a:defRPr sz="1200" kern="1200">
+        <a:solidFill>
+          <a:schemeClr val="tx1"/>
+        </a:solidFill>
+        <a:latin typeface="+mn-lt"/>
+        <a:ea typeface="+mn-ea"/>
+        <a:cs typeface="+mn-cs"/>
+      </a:defRPr>
+    </a:lvl5pPr>
+    <a:lvl6pPr marL="2286000" algn="l" defTabSz="914400" rtl="0" eaLnBrk="1" latinLnBrk="0" hangingPunct="1">
+      <a:defRPr sz="1200" kern="1200">
+        <a:solidFill>
+          <a:schemeClr val="tx1"/>
+        </a:solidFill>
+        <a:latin typeface="+mn-lt"/>
+        <a:ea typeface="+mn-ea"/>
+        <a:cs typeface="+mn-cs"/>
+      </a:defRPr>
+    </a:lvl6pPr>
+    <a:lvl7pPr marL="2743200" algn="l" defTabSz="914400" rtl="0" eaLnBrk="1" latinLnBrk="0" hangingPunct="1">
+      <a:defRPr sz="1200" kern="1200">
+        <a:solidFill>
+          <a:schemeClr val="tx1"/>
+        </a:solidFill>
+        <a:latin typeface="+mn-lt"/>
+        <a:ea typeface="+mn-ea"/>
+        <a:cs typeface="+mn-cs"/>
+      </a:defRPr>
+    </a:lvl7pPr>
+    <a:lvl8pPr marL="3200400" algn="l" defTabSz="914400" rtl="0" eaLnBrk="1" latinLnBrk="0" hangingPunct="1">
+      <a:defRPr sz="1200" kern="1200">
+        <a:solidFill>
+          <a:schemeClr val="tx1"/>
+        </a:solidFill>
+        <a:latin typeface="+mn-lt"/>
+        <a:ea typeface="+mn-ea"/>
+        <a:cs typeface="+mn-cs"/>
+      </a:defRPr>
+    </a:lvl8pPr>
+    <a:lvl9pPr marL="3657600" algn="l" defTabSz="914400" rtl="0" eaLnBrk="1" latinLnBrk="0" hangingPunct="1">
+      <a:defRPr sz="1200" kern="1200">
+        <a:solidFill>
+          <a:schemeClr val="tx1"/>
+        </a:solidFill>
+        <a:latin typeface="+mn-lt"/>
+        <a:ea typeface="+mn-ea"/>
+        <a:cs typeface="+mn-cs"/>
+      </a:defRPr>
+    </a:lvl9pPr>
+  </p:notesStyle>
+</p:notesMaster>
 </file>
 
 <file path=ppt/slideLayouts/slideLayout1.xml><?xml version="1.0" encoding="utf-8"?>
@@ -3084,6 +3436,14 @@
 <file path=ppt/slides/slide1.xml><?xml version="1.0" encoding="utf-8"?>
 <p:sld xmlns:a="http://schemas.openxmlformats.org/drawingml/2006/main" xmlns:r="http://schemas.openxmlformats.org/officeDocument/2006/relationships" xmlns:p="http://schemas.openxmlformats.org/presentationml/2006/main">
   <p:cSld>
+    <p:bg>
+      <p:bgPr>
+        <a:solidFill>
+          <a:schemeClr val="tx2"/>
+        </a:solidFill>
+        <a:effectLst/>
+      </p:bgPr>
+    </p:bg>
     <p:spTree>
       <p:nvGrpSpPr>
         <p:cNvPr id="1" name=""/>
@@ -3100,51 +3460,13 @@
       </p:grpSpPr>
       <p:sp>
         <p:nvSpPr>
-          <p:cNvPr id="2" name="Rectangle 1"/>
-          <p:cNvSpPr/>
-          <p:nvPr/>
-        </p:nvSpPr>
-        <p:spPr>
-          <a:xfrm>
-            <a:off x="0" y="0"/>
-            <a:ext cx="9144000" cy="5143500"/>
-          </a:xfrm>
-          <a:prstGeom prst="rect">
-            <a:avLst/>
-          </a:prstGeom>
-          <a:solidFill>
-            <a:srgbClr val="021F2E"/>
-          </a:solidFill>
-          <a:ln>
-            <a:noFill/>
-          </a:ln>
-        </p:spPr>
-        <p:style>
-          <a:lnRef idx="1">
-            <a:schemeClr val="accent1"/>
-          </a:lnRef>
-          <a:fillRef idx="3">
-            <a:schemeClr val="accent1"/>
-          </a:fillRef>
-          <a:effectRef idx="2">
-            <a:schemeClr val="accent1"/>
-          </a:effectRef>
-          <a:fontRef idx="minor">
-            <a:schemeClr val="lt1"/>
-          </a:fontRef>
-        </p:style>
-        <p:txBody>
-          <a:bodyPr rtlCol="0" anchor="ctr"/>
-          <a:lstStyle/>
-          <a:p>
-            <a:pPr algn="ctr"/>
-            <a:endParaRPr/>
-          </a:p>
-        </p:txBody>
-      </p:sp>
-      <p:sp>
-        <p:nvSpPr>
-          <p:cNvPr id="3" name="Rectangle 2"/>
+          <p:cNvPr id="2" name="Shape 0">
+            <a:extLst>
+              <a:ext uri="{FF2B5EF4-FFF2-40B4-BE49-F238E27FC236}">
+                <a16:creationId xmlns:a16="http://schemas.microsoft.com/office/drawing/2014/main" id="{D0C60134-697F-E50A-3A17-08E58582D3C3}"/>
+              </a:ext>
+            </a:extLst>
+          </p:cNvPr>
           <p:cNvSpPr/>
           <p:nvPr/>
         </p:nvSpPr>
@@ -3159,106 +3481,126 @@
           <a:solidFill>
             <a:srgbClr val="02C39A"/>
           </a:solidFill>
-          <a:ln>
-            <a:noFill/>
+          <a:ln w="12700">
+            <a:solidFill>
+              <a:srgbClr val="02C39A"/>
+            </a:solidFill>
+            <a:prstDash val="solid"/>
           </a:ln>
         </p:spPr>
-        <p:style>
-          <a:lnRef idx="1">
-            <a:schemeClr val="accent1"/>
-          </a:lnRef>
-          <a:fillRef idx="3">
-            <a:schemeClr val="accent1"/>
-          </a:fillRef>
-          <a:effectRef idx="2">
-            <a:schemeClr val="accent1"/>
-          </a:effectRef>
-          <a:fontRef idx="minor">
-            <a:schemeClr val="lt1"/>
-          </a:fontRef>
-        </p:style>
-        <p:txBody>
-          <a:bodyPr rtlCol="0" anchor="ctr"/>
-          <a:lstStyle/>
-          <a:p>
-            <a:pPr algn="ctr"/>
-            <a:endParaRPr/>
-          </a:p>
-        </p:txBody>
-      </p:sp>
-      <p:sp>
-        <p:nvSpPr>
-          <p:cNvPr id="4" name="TextBox 3"/>
-          <p:cNvSpPr txBox="1"/>
-          <p:nvPr/>
-        </p:nvSpPr>
-        <p:spPr>
-          <a:xfrm>
-            <a:off x="457200" y="1100000"/>
-            <a:ext cx="8412480" cy="900000"/>
+        <p:txBody>
+          <a:bodyPr/>
+          <a:lstStyle/>
+          <a:p>
+            <a:endParaRPr lang="en-US"/>
+          </a:p>
+        </p:txBody>
+      </p:sp>
+      <p:sp>
+        <p:nvSpPr>
+          <p:cNvPr id="3" name="Text 2">
+            <a:extLst>
+              <a:ext uri="{FF2B5EF4-FFF2-40B4-BE49-F238E27FC236}">
+                <a16:creationId xmlns:a16="http://schemas.microsoft.com/office/drawing/2014/main" id="{C5BF470C-9098-8238-81A4-EF7CEE32D072}"/>
+              </a:ext>
+            </a:extLst>
+          </p:cNvPr>
+          <p:cNvSpPr/>
+          <p:nvPr/>
+        </p:nvSpPr>
+        <p:spPr>
+          <a:xfrm>
+            <a:off x="457200" y="1188720"/>
+            <a:ext cx="8229600" cy="1005840"/>
           </a:xfrm>
           <a:prstGeom prst="rect">
             <a:avLst/>
           </a:prstGeom>
           <a:noFill/>
-        </p:spPr>
-        <p:txBody>
-          <a:bodyPr wrap="square"/>
-          <a:lstStyle/>
-          <a:p>
-            <a:pPr algn="l"/>
-            <a:r>
-              <a:rPr sz="4400" b="1" i="0">
+          <a:ln/>
+        </p:spPr>
+        <p:txBody>
+          <a:bodyPr wrap="square" lIns="0" tIns="0" rIns="0" bIns="0" rtlCol="0" anchor="ctr"/>
+          <a:lstStyle/>
+          <a:p>
+            <a:pPr marL="0" indent="0" algn="l">
+              <a:buNone/>
+            </a:pPr>
+            <a:r>
+              <a:rPr lang="en-US" sz="4400" b="1" dirty="0">
                 <a:solidFill>
                   <a:srgbClr val="FFFFFF"/>
                 </a:solidFill>
+                <a:latin typeface="Calibri" pitchFamily="34" charset="0"/>
+                <a:ea typeface="Calibri" pitchFamily="34" charset="-122"/>
+                <a:cs typeface="Calibri" pitchFamily="34" charset="-120"/>
               </a:rPr>
               <a:t>Mandarin Tone Coach</a:t>
             </a:r>
-          </a:p>
-        </p:txBody>
-      </p:sp>
-      <p:sp>
-        <p:nvSpPr>
-          <p:cNvPr id="5" name="TextBox 4"/>
-          <p:cNvSpPr txBox="1"/>
-          <p:nvPr/>
-        </p:nvSpPr>
-        <p:spPr>
-          <a:xfrm>
-            <a:off x="457200" y="2050000"/>
-            <a:ext cx="7500000" cy="480000"/>
+            <a:endParaRPr lang="en-US" sz="4400" dirty="0"/>
+          </a:p>
+        </p:txBody>
+      </p:sp>
+      <p:sp>
+        <p:nvSpPr>
+          <p:cNvPr id="4" name="Text 3">
+            <a:extLst>
+              <a:ext uri="{FF2B5EF4-FFF2-40B4-BE49-F238E27FC236}">
+                <a16:creationId xmlns:a16="http://schemas.microsoft.com/office/drawing/2014/main" id="{2CAA2DD1-2CDD-94A8-B052-54F6D4B7812B}"/>
+              </a:ext>
+            </a:extLst>
+          </p:cNvPr>
+          <p:cNvSpPr/>
+          <p:nvPr/>
+        </p:nvSpPr>
+        <p:spPr>
+          <a:xfrm>
+            <a:off x="457200" y="2125980"/>
+            <a:ext cx="7315200" cy="502920"/>
           </a:xfrm>
           <a:prstGeom prst="rect">
             <a:avLst/>
           </a:prstGeom>
           <a:noFill/>
-        </p:spPr>
-        <p:txBody>
-          <a:bodyPr wrap="square"/>
-          <a:lstStyle/>
-          <a:p>
-            <a:pPr algn="l"/>
-            <a:r>
-              <a:rPr sz="2200" b="0" i="0">
+          <a:ln/>
+        </p:spPr>
+        <p:txBody>
+          <a:bodyPr wrap="square" lIns="0" tIns="0" rIns="0" bIns="0" rtlCol="0" anchor="ctr"/>
+          <a:lstStyle/>
+          <a:p>
+            <a:pPr marL="0" indent="0" algn="l">
+              <a:buNone/>
+            </a:pPr>
+            <a:r>
+              <a:rPr lang="en-US" sz="2400" dirty="0">
                 <a:solidFill>
                   <a:srgbClr val="02C39A"/>
                 </a:solidFill>
+                <a:latin typeface="Calibri" pitchFamily="34" charset="0"/>
+                <a:ea typeface="Calibri" pitchFamily="34" charset="-122"/>
+                <a:cs typeface="Calibri" pitchFamily="34" charset="-120"/>
               </a:rPr>
               <a:t>Adaptive Pitch Feedback for L2 Mandarin Tone Learning</a:t>
             </a:r>
-          </a:p>
-        </p:txBody>
-      </p:sp>
-      <p:sp>
-        <p:nvSpPr>
-          <p:cNvPr id="6" name="Rectangle 5"/>
+            <a:endParaRPr lang="en-US" sz="2400" dirty="0"/>
+          </a:p>
+        </p:txBody>
+      </p:sp>
+      <p:sp>
+        <p:nvSpPr>
+          <p:cNvPr id="5" name="Shape 4">
+            <a:extLst>
+              <a:ext uri="{FF2B5EF4-FFF2-40B4-BE49-F238E27FC236}">
+                <a16:creationId xmlns:a16="http://schemas.microsoft.com/office/drawing/2014/main" id="{21789D60-B687-285E-2502-92AC3C814700}"/>
+              </a:ext>
+            </a:extLst>
+          </p:cNvPr>
           <p:cNvSpPr/>
           <p:nvPr/>
         </p:nvSpPr>
         <p:spPr>
           <a:xfrm>
-            <a:off x="457200" y="2700000"/>
+            <a:off x="457200" y="3323844"/>
             <a:ext cx="3657600" cy="36576"/>
           </a:xfrm>
           <a:prstGeom prst="rect">
@@ -3267,157 +3609,213 @@
           <a:solidFill>
             <a:srgbClr val="1C7293"/>
           </a:solidFill>
-          <a:ln>
-            <a:noFill/>
+          <a:ln w="12700">
+            <a:solidFill>
+              <a:srgbClr val="1C7293"/>
+            </a:solidFill>
+            <a:prstDash val="solid"/>
           </a:ln>
         </p:spPr>
-        <p:style>
-          <a:lnRef idx="1">
-            <a:schemeClr val="accent1"/>
-          </a:lnRef>
-          <a:fillRef idx="3">
-            <a:schemeClr val="accent1"/>
-          </a:fillRef>
-          <a:effectRef idx="2">
-            <a:schemeClr val="accent1"/>
-          </a:effectRef>
-          <a:fontRef idx="minor">
-            <a:schemeClr val="lt1"/>
-          </a:fontRef>
-        </p:style>
-        <p:txBody>
-          <a:bodyPr rtlCol="0" anchor="ctr"/>
-          <a:lstStyle/>
-          <a:p>
-            <a:pPr algn="ctr"/>
-            <a:endParaRPr/>
-          </a:p>
-        </p:txBody>
-      </p:sp>
-      <p:sp>
-        <p:nvSpPr>
-          <p:cNvPr id="7" name="TextBox 6"/>
-          <p:cNvSpPr txBox="1"/>
-          <p:nvPr/>
-        </p:nvSpPr>
-        <p:spPr>
-          <a:xfrm>
-            <a:off x="457200" y="2800000"/>
-            <a:ext cx="8412480" cy="750000"/>
+        <p:txBody>
+          <a:bodyPr/>
+          <a:lstStyle/>
+          <a:p>
+            <a:endParaRPr lang="en-US"/>
+          </a:p>
+        </p:txBody>
+      </p:sp>
+      <p:sp>
+        <p:nvSpPr>
+          <p:cNvPr id="6" name="Text 5">
+            <a:extLst>
+              <a:ext uri="{FF2B5EF4-FFF2-40B4-BE49-F238E27FC236}">
+                <a16:creationId xmlns:a16="http://schemas.microsoft.com/office/drawing/2014/main" id="{2EAB782B-8473-3B6D-5D40-14D4A1CCF4FD}"/>
+              </a:ext>
+            </a:extLst>
+          </p:cNvPr>
+          <p:cNvSpPr/>
+          <p:nvPr/>
+        </p:nvSpPr>
+        <p:spPr>
+          <a:xfrm>
+            <a:off x="457200" y="3518154"/>
+            <a:ext cx="8229600" cy="822960"/>
           </a:xfrm>
           <a:prstGeom prst="rect">
             <a:avLst/>
           </a:prstGeom>
           <a:noFill/>
-        </p:spPr>
-        <p:txBody>
-          <a:bodyPr wrap="square"/>
-          <a:lstStyle/>
-          <a:p>
-            <a:pPr algn="l"/>
-            <a:r>
-              <a:rPr sz="1400" b="0" i="0">
+          <a:ln/>
+        </p:spPr>
+        <p:txBody>
+          <a:bodyPr wrap="square" lIns="0" tIns="0" rIns="0" bIns="0" rtlCol="0" anchor="ctr"/>
+          <a:lstStyle/>
+          <a:p>
+            <a:pPr marL="0" indent="0" algn="l">
+              <a:buNone/>
+            </a:pPr>
+            <a:r>
+              <a:rPr lang="en-US" dirty="0">
                 <a:solidFill>
                   <a:srgbClr val="CADCFC"/>
                 </a:solidFill>
+                <a:latin typeface="Calibri" pitchFamily="34" charset="0"/>
+                <a:ea typeface="Calibri" pitchFamily="34" charset="-122"/>
+                <a:cs typeface="Calibri" pitchFamily="34" charset="-120"/>
               </a:rPr>
               <a:t>Bharath Jagadish (bjagadish3@gatech.edu)</a:t>
             </a:r>
-          </a:p>
-          <a:p>
-            <a:pPr algn="l">
-              <a:spcBef>
-                <a:spcPts val="400"/>
-              </a:spcBef>
+            <a:endParaRPr lang="en-US" dirty="0"/>
+          </a:p>
+          <a:p>
+            <a:pPr marL="0" indent="0" algn="l">
+              <a:buNone/>
             </a:pPr>
             <a:r>
-              <a:rPr sz="1400" b="0" i="0">
+              <a:rPr lang="en-US" dirty="0">
                 <a:solidFill>
                   <a:srgbClr val="CADCFC"/>
                 </a:solidFill>
-              </a:rPr>
-              <a:t>CS6460 Educational Technology  ·  Georgia Tech</a:t>
-            </a:r>
-          </a:p>
-        </p:txBody>
-      </p:sp>
-      <p:sp>
-        <p:nvSpPr>
-          <p:cNvPr id="8" name="Rectangle 7"/>
+                <a:latin typeface="Calibri" pitchFamily="34" charset="0"/>
+                <a:ea typeface="Calibri" pitchFamily="34" charset="-122"/>
+                <a:cs typeface="Calibri" pitchFamily="34" charset="-120"/>
+              </a:rPr>
+              <a:t>CS6460 Educational Technology</a:t>
+            </a:r>
+          </a:p>
+          <a:p>
+            <a:pPr marL="0" indent="0" algn="l">
+              <a:buNone/>
+            </a:pPr>
+            <a:r>
+              <a:rPr lang="en-US" dirty="0">
+                <a:solidFill>
+                  <a:srgbClr val="CADCFC"/>
+                </a:solidFill>
+                <a:latin typeface="Calibri" pitchFamily="34" charset="0"/>
+                <a:ea typeface="Calibri" pitchFamily="34" charset="-122"/>
+                <a:cs typeface="Calibri" pitchFamily="34" charset="-120"/>
+              </a:rPr>
+              <a:t>Georgia Tech</a:t>
+            </a:r>
+            <a:endParaRPr lang="en-US" dirty="0"/>
+          </a:p>
+        </p:txBody>
+      </p:sp>
+      <p:sp>
+        <p:nvSpPr>
+          <p:cNvPr id="8" name="Shape 6">
+            <a:extLst>
+              <a:ext uri="{FF2B5EF4-FFF2-40B4-BE49-F238E27FC236}">
+                <a16:creationId xmlns:a16="http://schemas.microsoft.com/office/drawing/2014/main" id="{BE1C3CCF-1B22-CF19-AF3B-C158C319BE9D}"/>
+              </a:ext>
+            </a:extLst>
+          </p:cNvPr>
           <p:cNvSpPr/>
           <p:nvPr/>
         </p:nvSpPr>
         <p:spPr>
           <a:xfrm>
-            <a:off x="457200" y="4366260"/>
+            <a:off x="457200" y="2754630"/>
             <a:ext cx="1737360" cy="411480"/>
           </a:xfrm>
-          <a:prstGeom prst="rect">
-            <a:avLst/>
+          <a:prstGeom prst="roundRect">
+            <a:avLst>
+              <a:gd name="adj" fmla="val 17778"/>
+            </a:avLst>
           </a:prstGeom>
           <a:solidFill>
             <a:srgbClr val="02C39A"/>
           </a:solidFill>
-          <a:ln>
-            <a:noFill/>
+          <a:ln w="12700">
+            <a:solidFill>
+              <a:srgbClr val="02C39A"/>
+            </a:solidFill>
+            <a:prstDash val="solid"/>
           </a:ln>
         </p:spPr>
-        <p:style>
-          <a:lnRef idx="1">
-            <a:schemeClr val="accent1"/>
-          </a:lnRef>
-          <a:fillRef idx="3">
-            <a:schemeClr val="accent1"/>
-          </a:fillRef>
-          <a:effectRef idx="2">
-            <a:schemeClr val="accent1"/>
-          </a:effectRef>
-          <a:fontRef idx="minor">
-            <a:schemeClr val="lt1"/>
-          </a:fontRef>
-        </p:style>
-        <p:txBody>
-          <a:bodyPr rtlCol="0" anchor="ctr"/>
+        <p:txBody>
+          <a:bodyPr/>
           <a:lstStyle/>
           <a:p>
             <a:pPr algn="ctr"/>
-            <a:endParaRPr/>
-          </a:p>
-        </p:txBody>
-      </p:sp>
-      <p:sp>
-        <p:nvSpPr>
-          <p:cNvPr id="9" name="TextBox 8"/>
-          <p:cNvSpPr txBox="1"/>
-          <p:nvPr/>
-        </p:nvSpPr>
-        <p:spPr>
-          <a:xfrm>
-            <a:off x="457200" y="4366260"/>
+            <a:r>
+              <a:rPr lang="en-US" dirty="0">
+                <a:solidFill>
+                  <a:schemeClr val="bg1"/>
+                </a:solidFill>
+                <a:latin typeface="Calibri" panose="020F0502020204030204" pitchFamily="34" charset="0"/>
+                <a:cs typeface="Calibri" panose="020F0502020204030204" pitchFamily="34" charset="0"/>
+              </a:rPr>
+              <a:t>Milestone 2</a:t>
+            </a:r>
+          </a:p>
+        </p:txBody>
+      </p:sp>
+      <p:sp>
+        <p:nvSpPr>
+          <p:cNvPr id="9" name="Shape 6">
+            <a:extLst>
+              <a:ext uri="{FF2B5EF4-FFF2-40B4-BE49-F238E27FC236}">
+                <a16:creationId xmlns:a16="http://schemas.microsoft.com/office/drawing/2014/main" id="{E6365814-1AA1-9C22-0F58-B2B8076C8C0E}"/>
+              </a:ext>
+            </a:extLst>
+          </p:cNvPr>
+          <p:cNvSpPr/>
+          <p:nvPr/>
+        </p:nvSpPr>
+        <p:spPr>
+          <a:xfrm>
+            <a:off x="2377440" y="2754630"/>
             <a:ext cx="1737360" cy="411480"/>
           </a:xfrm>
-          <a:prstGeom prst="rect">
-            <a:avLst/>
-          </a:prstGeom>
-          <a:noFill/>
-        </p:spPr>
-        <p:txBody>
-          <a:bodyPr wrap="square"/>
+          <a:prstGeom prst="roundRect">
+            <a:avLst>
+              <a:gd name="adj" fmla="val 17778"/>
+            </a:avLst>
+          </a:prstGeom>
+          <a:solidFill>
+            <a:srgbClr val="02C39A"/>
+          </a:solidFill>
+          <a:ln w="12700">
+            <a:solidFill>
+              <a:srgbClr val="02C39A"/>
+            </a:solidFill>
+            <a:prstDash val="solid"/>
+          </a:ln>
+        </p:spPr>
+        <p:txBody>
+          <a:bodyPr/>
           <a:lstStyle/>
           <a:p>
             <a:pPr algn="ctr"/>
             <a:r>
-              <a:rPr sz="1400" b="1" i="0">
-                <a:solidFill>
-                  <a:srgbClr val="065A82"/>
-                </a:solidFill>
-              </a:rPr>
-              <a:t>Milestone 2</a:t>
-            </a:r>
+              <a:rPr lang="en-US" dirty="0">
+                <a:solidFill>
+                  <a:schemeClr val="bg1"/>
+                </a:solidFill>
+                <a:latin typeface="Calibri" panose="020F0502020204030204" pitchFamily="34" charset="0"/>
+                <a:cs typeface="Calibri" panose="020F0502020204030204" pitchFamily="34" charset="0"/>
+                <a:hlinkClick r:id="rId2"/>
+              </a:rPr>
+              <a:t>Video Link</a:t>
+            </a:r>
+            <a:endParaRPr lang="en-US" dirty="0">
+              <a:solidFill>
+                <a:schemeClr val="bg1"/>
+              </a:solidFill>
+              <a:latin typeface="Calibri" panose="020F0502020204030204" pitchFamily="34" charset="0"/>
+              <a:cs typeface="Calibri" panose="020F0502020204030204" pitchFamily="34" charset="0"/>
+            </a:endParaRPr>
           </a:p>
         </p:txBody>
       </p:sp>
     </p:spTree>
+    <p:extLst>
+      <p:ext uri="{BB962C8B-B14F-4D97-AF65-F5344CB8AC3E}">
+        <p14:creationId xmlns:p14="http://schemas.microsoft.com/office/powerpoint/2010/main" val="2043069685"/>
+      </p:ext>
+    </p:extLst>
   </p:cSld>
   <p:clrMapOvr>
     <a:masterClrMapping/>
@@ -3482,7 +3880,7 @@
           <a:lstStyle/>
           <a:p>
             <a:pPr algn="ctr"/>
-            <a:endParaRPr/>
+            <a:endParaRPr dirty="0"/>
           </a:p>
         </p:txBody>
       </p:sp>
@@ -3503,12 +3901,12 @@
           <a:noFill/>
         </p:spPr>
         <p:txBody>
-          <a:bodyPr wrap="square"/>
-          <a:lstStyle/>
-          <a:p>
-            <a:pPr algn="l"/>
-            <a:r>
-              <a:rPr sz="2000" b="1" i="0">
+          <a:bodyPr wrap="square" anchor="ctr"/>
+          <a:lstStyle/>
+          <a:p>
+            <a:pPr algn="l"/>
+            <a:r>
+              <a:rPr sz="2600" b="1" i="0" dirty="0">
                 <a:solidFill>
                   <a:srgbClr val="FFFFFF"/>
                 </a:solidFill>
@@ -3527,7 +3925,7 @@
         <p:spPr>
           <a:xfrm>
             <a:off x="274320" y="960120"/>
-            <a:ext cx="4115520" cy="4000500"/>
+            <a:ext cx="3828553" cy="4000500"/>
           </a:xfrm>
           <a:prstGeom prst="rect">
             <a:avLst/>
@@ -3571,7 +3969,7 @@
         <p:spPr>
           <a:xfrm>
             <a:off x="274320" y="960120"/>
-            <a:ext cx="4115520" cy="320040"/>
+            <a:ext cx="3828553" cy="320040"/>
           </a:xfrm>
           <a:prstGeom prst="rect">
             <a:avLst/>
@@ -3623,12 +4021,12 @@
           <a:noFill/>
         </p:spPr>
         <p:txBody>
-          <a:bodyPr wrap="square"/>
-          <a:lstStyle/>
-          <a:p>
-            <a:pPr algn="l"/>
-            <a:r>
-              <a:rPr sz="1400" b="1" i="0">
+          <a:bodyPr wrap="square" anchor="ctr"/>
+          <a:lstStyle/>
+          <a:p>
+            <a:pPr algn="l"/>
+            <a:r>
+              <a:rPr sz="1400" b="1" i="0" dirty="0">
                 <a:solidFill>
                   <a:srgbClr val="FFFFFF"/>
                 </a:solidFill>
@@ -3646,7 +4044,7 @@
         </p:nvSpPr>
         <p:spPr>
           <a:xfrm>
-            <a:off x="457200" y="1463040"/>
+            <a:off x="274320" y="1440181"/>
             <a:ext cx="3749760" cy="3314700"/>
           </a:xfrm>
           <a:prstGeom prst="rect">
@@ -3660,17 +4058,25 @@
           <a:p>
             <a:pPr algn="l"/>
             <a:r>
-              <a:rPr sz="1200" b="1" i="0">
+              <a:rPr sz="1200" b="1" i="0" dirty="0" err="1">
                 <a:solidFill>
                   <a:srgbClr val="065A82"/>
                 </a:solidFill>
               </a:rPr>
-              <a:t>Streamlit web app — real-time Mandarin tone practice</a:t>
-            </a:r>
-          </a:p>
-          <a:p>
-            <a:pPr algn="l"/>
-            <a:endParaRPr sz="1200" b="1" i="0">
+              <a:t>Streamlit</a:t>
+            </a:r>
+            <a:r>
+              <a:rPr sz="1200" b="1" i="0" dirty="0">
+                <a:solidFill>
+                  <a:srgbClr val="065A82"/>
+                </a:solidFill>
+              </a:rPr>
+              <a:t> web app — real-time Mandarin tone practice</a:t>
+            </a:r>
+          </a:p>
+          <a:p>
+            <a:pPr algn="l"/>
+            <a:endParaRPr sz="1200" b="1" i="0" dirty="0">
               <a:solidFill>
                 <a:srgbClr val="065A82"/>
               </a:solidFill>
@@ -3679,17 +4085,13 @@
           <a:p>
             <a:pPr algn="l"/>
             <a:r>
-              <a:rPr sz="1000" b="0" i="0">
-                <a:solidFill>
-                  <a:srgbClr val="5A7A8A"/>
-                </a:solidFill>
-              </a:rPr>
+              <a:rPr sz="1000" b="1" i="0" dirty="0"/>
               <a:t>Pipeline: Record → Extract F0 → Classify → Visualize → Feedback</a:t>
             </a:r>
           </a:p>
           <a:p>
             <a:pPr algn="l"/>
-            <a:endParaRPr sz="1000" b="0" i="0">
+            <a:endParaRPr sz="1000" b="0" i="0" dirty="0">
               <a:solidFill>
                 <a:srgbClr val="5A7A8A"/>
               </a:solidFill>
@@ -3698,7 +4100,7 @@
           <a:p>
             <a:pPr algn="l"/>
             <a:r>
-              <a:rPr sz="1100" b="1" i="0">
+              <a:rPr sz="1100" b="1" i="0" dirty="0">
                 <a:solidFill>
                   <a:srgbClr val="065A82"/>
                 </a:solidFill>
@@ -3709,7 +4111,7 @@
           <a:p>
             <a:pPr algn="l"/>
             <a:r>
-              <a:rPr sz="1000" b="0" i="0">
+              <a:rPr sz="1000" b="0" i="0" dirty="0">
                 <a:solidFill>
                   <a:srgbClr val="1A2B3C"/>
                 </a:solidFill>
@@ -3720,7 +4122,7 @@
           <a:p>
             <a:pPr algn="l"/>
             <a:r>
-              <a:rPr sz="1000" b="0" i="0">
+              <a:rPr sz="1000" b="0" i="0" dirty="0">
                 <a:solidFill>
                   <a:srgbClr val="1A2B3C"/>
                 </a:solidFill>
@@ -3731,7 +4133,7 @@
           <a:p>
             <a:pPr algn="l"/>
             <a:r>
-              <a:rPr sz="1000" b="0" i="0">
+              <a:rPr sz="1000" b="0" i="0" dirty="0">
                 <a:solidFill>
                   <a:srgbClr val="1A2B3C"/>
                 </a:solidFill>
@@ -3741,7 +4143,7 @@
           </a:p>
           <a:p>
             <a:pPr algn="l"/>
-            <a:endParaRPr sz="1000" b="0" i="0">
+            <a:endParaRPr sz="1000" b="0" i="0" dirty="0">
               <a:solidFill>
                 <a:srgbClr val="1A2B3C"/>
               </a:solidFill>
@@ -3750,7 +4152,7 @@
           <a:p>
             <a:pPr algn="l"/>
             <a:r>
-              <a:rPr sz="1100" b="1" i="0">
+              <a:rPr sz="1100" b="1" i="0" dirty="0">
                 <a:solidFill>
                   <a:srgbClr val="065A82"/>
                 </a:solidFill>
@@ -3761,7 +4163,7 @@
           <a:p>
             <a:pPr algn="l"/>
             <a:r>
-              <a:rPr sz="1000" b="0" i="0">
+              <a:rPr sz="1000" b="0" i="0" dirty="0">
                 <a:solidFill>
                   <a:srgbClr val="1A2B3C"/>
                 </a:solidFill>
@@ -3772,7 +4174,7 @@
           <a:p>
             <a:pPr algn="l"/>
             <a:r>
-              <a:rPr sz="1000" b="0" i="0">
+              <a:rPr sz="1000" b="0" i="0" dirty="0">
                 <a:solidFill>
                   <a:srgbClr val="1A2B3C"/>
                 </a:solidFill>
@@ -3783,7 +4185,7 @@
           <a:p>
             <a:pPr algn="l"/>
             <a:r>
-              <a:rPr sz="1000" b="0" i="0">
+              <a:rPr sz="1000" b="0" i="0" dirty="0">
                 <a:solidFill>
                   <a:srgbClr val="1A2B3C"/>
                 </a:solidFill>
@@ -3794,7 +4196,7 @@
           <a:p>
             <a:pPr algn="l"/>
             <a:r>
-              <a:rPr sz="1000" b="0" i="0">
+              <a:rPr sz="1000" b="0" i="0" dirty="0">
                 <a:solidFill>
                   <a:srgbClr val="1A2B3C"/>
                 </a:solidFill>
@@ -3804,300 +4206,36 @@
           </a:p>
         </p:txBody>
       </p:sp>
-      <p:sp>
-        <p:nvSpPr>
-          <p:cNvPr id="8" name="Rectangle 7"/>
-          <p:cNvSpPr/>
-          <p:nvPr/>
-        </p:nvSpPr>
-        <p:spPr>
-          <a:xfrm>
-            <a:off x="4572720" y="960120"/>
-            <a:ext cx="4115520" cy="4000500"/>
-          </a:xfrm>
-          <a:prstGeom prst="rect">
-            <a:avLst/>
-          </a:prstGeom>
-          <a:solidFill>
-            <a:srgbClr val="FFFFFF"/>
-          </a:solidFill>
-          <a:ln>
-            <a:noFill/>
-          </a:ln>
-        </p:spPr>
-        <p:style>
-          <a:lnRef idx="1">
-            <a:schemeClr val="accent1"/>
-          </a:lnRef>
-          <a:fillRef idx="3">
-            <a:schemeClr val="accent1"/>
-          </a:fillRef>
-          <a:effectRef idx="2">
-            <a:schemeClr val="accent1"/>
-          </a:effectRef>
-          <a:fontRef idx="minor">
-            <a:schemeClr val="lt1"/>
-          </a:fontRef>
-        </p:style>
-        <p:txBody>
-          <a:bodyPr rtlCol="0" anchor="ctr"/>
-          <a:lstStyle/>
-          <a:p>
-            <a:pPr algn="ctr"/>
-            <a:endParaRPr/>
-          </a:p>
-        </p:txBody>
-      </p:sp>
-      <p:sp>
-        <p:nvSpPr>
-          <p:cNvPr id="9" name="Rectangle 8"/>
-          <p:cNvSpPr/>
-          <p:nvPr/>
-        </p:nvSpPr>
-        <p:spPr>
-          <a:xfrm>
-            <a:off x="4572720" y="960120"/>
-            <a:ext cx="4115520" cy="320040"/>
-          </a:xfrm>
-          <a:prstGeom prst="rect">
-            <a:avLst/>
-          </a:prstGeom>
-          <a:solidFill>
-            <a:srgbClr val="02C39A"/>
-          </a:solidFill>
-          <a:ln>
-            <a:noFill/>
-          </a:ln>
-        </p:spPr>
-        <p:style>
-          <a:lnRef idx="1">
-            <a:schemeClr val="accent1"/>
-          </a:lnRef>
-          <a:fillRef idx="3">
-            <a:schemeClr val="accent1"/>
-          </a:fillRef>
-          <a:effectRef idx="2">
-            <a:schemeClr val="accent1"/>
-          </a:effectRef>
-          <a:fontRef idx="minor">
-            <a:schemeClr val="lt1"/>
-          </a:fontRef>
-        </p:style>
-        <p:txBody>
-          <a:bodyPr rtlCol="0" anchor="ctr"/>
-          <a:lstStyle/>
-          <a:p>
-            <a:pPr algn="ctr"/>
-            <a:endParaRPr/>
-          </a:p>
-        </p:txBody>
-      </p:sp>
-      <p:sp>
-        <p:nvSpPr>
-          <p:cNvPr id="10" name="TextBox 9"/>
-          <p:cNvSpPr txBox="1"/>
-          <p:nvPr/>
-        </p:nvSpPr>
-        <p:spPr>
-          <a:xfrm>
-            <a:off x="4664160" y="1051560"/>
-            <a:ext cx="3932640" cy="228600"/>
-          </a:xfrm>
-          <a:prstGeom prst="rect">
-            <a:avLst/>
-          </a:prstGeom>
-          <a:noFill/>
-        </p:spPr>
-        <p:txBody>
-          <a:bodyPr wrap="square"/>
-          <a:lstStyle/>
-          <a:p>
-            <a:pPr algn="l"/>
-            <a:r>
-              <a:rPr sz="1400" b="1" i="0">
-                <a:solidFill>
-                  <a:srgbClr val="FFFFFF"/>
-                </a:solidFill>
-              </a:rPr>
-              <a:t>Improvements Since Milestone 1</a:t>
-            </a:r>
-          </a:p>
-        </p:txBody>
-      </p:sp>
-      <p:sp>
-        <p:nvSpPr>
-          <p:cNvPr id="11" name="TextBox 10"/>
-          <p:cNvSpPr txBox="1"/>
-          <p:nvPr/>
-        </p:nvSpPr>
-        <p:spPr>
-          <a:xfrm>
-            <a:off x="4755600" y="1463040"/>
-            <a:ext cx="3749760" cy="3314700"/>
-          </a:xfrm>
-          <a:prstGeom prst="rect">
-            <a:avLst/>
-          </a:prstGeom>
-          <a:noFill/>
-        </p:spPr>
-        <p:txBody>
-          <a:bodyPr wrap="square"/>
-          <a:lstStyle/>
-          <a:p>
-            <a:pPr algn="l"/>
-            <a:r>
-              <a:rPr sz="1100" b="1" i="0">
-                <a:solidFill>
-                  <a:srgbClr val="02C39A"/>
-                </a:solidFill>
-              </a:rPr>
-              <a:t>Disyllabic Practice Mode</a:t>
-            </a:r>
-          </a:p>
-          <a:p>
-            <a:pPr algn="l"/>
-            <a:r>
-              <a:rPr sz="1000" b="0" i="0">
-                <a:solidFill>
-                  <a:srgbClr val="1A2B3C"/>
-                </a:solidFill>
-              </a:rPr>
-              <a:t>Energy-minimum syllable boundary detection; neutral-tone handling; 20-word list</a:t>
-            </a:r>
-          </a:p>
-          <a:p>
-            <a:pPr algn="l"/>
-            <a:endParaRPr sz="1000" b="0" i="0">
-              <a:solidFill>
-                <a:srgbClr val="1A2B3C"/>
-              </a:solidFill>
-            </a:endParaRPr>
-          </a:p>
-          <a:p>
-            <a:pPr algn="l"/>
-            <a:r>
-              <a:rPr sz="1100" b="1" i="0">
-                <a:solidFill>
-                  <a:srgbClr val="2196F3"/>
-                </a:solidFill>
-              </a:rPr>
-              <a:t>Evaluation Instruments</a:t>
-            </a:r>
-          </a:p>
-          <a:p>
-            <a:pPr algn="l"/>
-            <a:r>
-              <a:rPr sz="1000" b="0" i="0">
-                <a:solidFill>
-                  <a:srgbClr val="1A2B3C"/>
-                </a:solidFill>
-              </a:rPr>
-              <a:t>Pre/post perception test (Forms A &amp; B, different speakers, Google Sheets logging)</a:t>
-            </a:r>
-          </a:p>
-          <a:p>
-            <a:pPr algn="l"/>
-            <a:r>
-              <a:rPr sz="1000" b="0" i="0">
-                <a:solidFill>
-                  <a:srgbClr val="1A2B3C"/>
-                </a:solidFill>
-              </a:rPr>
-              <a:t>TAM usability survey — 8 Likert items + open-ended feedback</a:t>
-            </a:r>
-          </a:p>
-          <a:p>
-            <a:pPr algn="l"/>
-            <a:endParaRPr sz="1000" b="0" i="0">
-              <a:solidFill>
-                <a:srgbClr val="1A2B3C"/>
-              </a:solidFill>
-            </a:endParaRPr>
-          </a:p>
-          <a:p>
-            <a:pPr algn="l"/>
-            <a:r>
-              <a:rPr sz="1100" b="1" i="0">
-                <a:solidFill>
-                  <a:srgbClr val="4CAF50"/>
-                </a:solidFill>
-              </a:rPr>
-              <a:t>Usability Fixes</a:t>
-            </a:r>
-          </a:p>
-          <a:p>
-            <a:pPr algn="l"/>
-            <a:r>
-              <a:rPr sz="1000" b="0" i="0">
-                <a:solidFill>
-                  <a:srgbClr val="1A2B3C"/>
-                </a:solidFill>
-              </a:rPr>
-              <a:t>Tone descriptions in sidebar; stale-result bug fixed; Streamlit header hidden; dividers repositioned</a:t>
-            </a:r>
-          </a:p>
-          <a:p>
-            <a:pPr algn="l"/>
-            <a:endParaRPr sz="1000" b="0" i="0">
-              <a:solidFill>
-                <a:srgbClr val="1A2B3C"/>
-              </a:solidFill>
-            </a:endParaRPr>
-          </a:p>
-          <a:p>
-            <a:pPr algn="l"/>
-            <a:r>
-              <a:rPr sz="1100" b="1" i="0">
-                <a:solidFill>
-                  <a:srgbClr val="FF9800"/>
-                </a:solidFill>
-              </a:rPr>
-              <a:t>Data Fixes</a:t>
-            </a:r>
-          </a:p>
-          <a:p>
-            <a:pPr algn="l"/>
-            <a:r>
-              <a:rPr sz="1000" b="0" i="0">
-                <a:solidFill>
-                  <a:srgbClr val="1A2B3C"/>
-                </a:solidFill>
-              </a:rPr>
-              <a:t>shàngkē tone corrected (T4+T4); neutral-tone syllable window widened to 25–85%</a:t>
-            </a:r>
-          </a:p>
-          <a:p>
-            <a:pPr algn="l"/>
-            <a:endParaRPr sz="1000" b="0" i="0">
-              <a:solidFill>
-                <a:srgbClr val="1A2B3C"/>
-              </a:solidFill>
-            </a:endParaRPr>
-          </a:p>
-          <a:p>
-            <a:pPr algn="l"/>
-            <a:r>
-              <a:rPr sz="1100" b="1" i="0">
-                <a:solidFill>
-                  <a:srgbClr val="065A82"/>
-                </a:solidFill>
-              </a:rPr>
-              <a:t>UI Polish</a:t>
-            </a:r>
-          </a:p>
-          <a:p>
-            <a:pPr algn="l"/>
-            <a:r>
-              <a:rPr sz="1000" b="0" i="0">
-                <a:solidFill>
-                  <a:srgbClr val="1A2B3C"/>
-                </a:solidFill>
-              </a:rPr>
-              <a:t>Disyllabic tone badges use flex layout; footer text removed; toolbar minimised</a:t>
-            </a:r>
-          </a:p>
-        </p:txBody>
-      </p:sp>
+      <p:pic>
+        <p:nvPicPr>
+          <p:cNvPr id="14" name="Picture 13">
+            <a:extLst>
+              <a:ext uri="{FF2B5EF4-FFF2-40B4-BE49-F238E27FC236}">
+                <a16:creationId xmlns:a16="http://schemas.microsoft.com/office/drawing/2014/main" id="{0255DACF-F2E6-6A07-FBDF-028E3636C37B}"/>
+              </a:ext>
+            </a:extLst>
+          </p:cNvPr>
+          <p:cNvPicPr>
+            <a:picLocks noChangeAspect="1"/>
+          </p:cNvPicPr>
+          <p:nvPr/>
+        </p:nvPicPr>
+        <p:blipFill>
+          <a:blip r:embed="rId2"/>
+          <a:stretch>
+            <a:fillRect/>
+          </a:stretch>
+        </p:blipFill>
+        <p:spPr>
+          <a:xfrm>
+            <a:off x="4150474" y="1280160"/>
+            <a:ext cx="4869791" cy="3053301"/>
+          </a:xfrm>
+          <a:prstGeom prst="rect">
+            <a:avLst/>
+          </a:prstGeom>
+        </p:spPr>
+      </p:pic>
     </p:spTree>
   </p:cSld>
   <p:clrMapOvr>
@@ -4184,12 +4322,12 @@
           <a:noFill/>
         </p:spPr>
         <p:txBody>
-          <a:bodyPr wrap="square"/>
-          <a:lstStyle/>
-          <a:p>
-            <a:pPr algn="l"/>
-            <a:r>
-              <a:rPr sz="2000" b="1" i="0">
+          <a:bodyPr wrap="square" anchor="ctr"/>
+          <a:lstStyle/>
+          <a:p>
+            <a:pPr algn="l"/>
+            <a:r>
+              <a:rPr sz="2600" b="1" i="0" dirty="0">
                 <a:solidFill>
                   <a:srgbClr val="FFFFFF"/>
                 </a:solidFill>
@@ -4304,12 +4442,12 @@
           <a:noFill/>
         </p:spPr>
         <p:txBody>
-          <a:bodyPr wrap="square"/>
-          <a:lstStyle/>
-          <a:p>
-            <a:pPr algn="l"/>
-            <a:r>
-              <a:rPr sz="1400" b="1" i="0">
+          <a:bodyPr wrap="square" anchor="ctr"/>
+          <a:lstStyle/>
+          <a:p>
+            <a:pPr algn="l"/>
+            <a:r>
+              <a:rPr sz="1400" b="1" i="0" dirty="0">
                 <a:solidFill>
                   <a:srgbClr val="FFFFFF"/>
                 </a:solidFill>
@@ -4341,29 +4479,85 @@
           <a:p>
             <a:pPr algn="l"/>
             <a:r>
-              <a:rPr sz="1200" b="1" i="0">
+              <a:rPr lang="en-US" sz="1200" b="1" dirty="0">
                 <a:solidFill>
                   <a:srgbClr val="065A82"/>
                 </a:solidFill>
               </a:rPr>
-              <a:t>19 perception test · 16 TAM survey · CS6460 classmates</a:t>
-            </a:r>
-          </a:p>
-          <a:p>
-            <a:pPr algn="l"/>
-            <a:r>
-              <a:rPr sz="1100" b="0" i="0">
+              <a:t>P</a:t>
+            </a:r>
+            <a:r>
+              <a:rPr sz="1200" b="1" i="0" dirty="0">
+                <a:solidFill>
+                  <a:srgbClr val="065A82"/>
+                </a:solidFill>
+              </a:rPr>
+              <a:t>erception test </a:t>
+            </a:r>
+            <a:r>
+              <a:rPr lang="en-US" sz="1200" b="1" i="0" dirty="0">
+                <a:solidFill>
+                  <a:srgbClr val="065A82"/>
+                </a:solidFill>
+              </a:rPr>
+              <a:t>&amp;</a:t>
+            </a:r>
+            <a:r>
+              <a:rPr sz="1200" b="1" i="0" dirty="0">
+                <a:solidFill>
+                  <a:srgbClr val="065A82"/>
+                </a:solidFill>
+              </a:rPr>
+              <a:t> </a:t>
+            </a:r>
+            <a:r>
+              <a:rPr lang="en-US" sz="1200" b="1" i="0" dirty="0">
+                <a:solidFill>
+                  <a:srgbClr val="065A82"/>
+                </a:solidFill>
+              </a:rPr>
+              <a:t>Tech. Acceptance Model</a:t>
+            </a:r>
+            <a:r>
+              <a:rPr sz="1200" b="1" i="0" dirty="0">
+                <a:solidFill>
+                  <a:srgbClr val="065A82"/>
+                </a:solidFill>
+              </a:rPr>
+              <a:t> </a:t>
+            </a:r>
+            <a:r>
+              <a:rPr lang="en-US" sz="1200" b="1" i="0" dirty="0">
+                <a:solidFill>
+                  <a:srgbClr val="065A82"/>
+                </a:solidFill>
+              </a:rPr>
+              <a:t>(TAM) </a:t>
+            </a:r>
+            <a:r>
+              <a:rPr sz="1200" b="1" i="0" dirty="0">
+                <a:solidFill>
+                  <a:srgbClr val="065A82"/>
+                </a:solidFill>
+              </a:rPr>
+              <a:t>survey</a:t>
+            </a:r>
+          </a:p>
+          <a:p>
+            <a:pPr algn="l"/>
+            <a:r>
+              <a:rPr sz="1100" b="0" i="0" dirty="0">
                 <a:solidFill>
                   <a:srgbClr val="1A2B3C"/>
                 </a:solidFill>
               </a:rPr>
-              <a:t>Online, asynchronous, self-paced (~10–15 min)</a:t>
-            </a:r>
-          </a:p>
-          <a:p>
-            <a:pPr algn="l"/>
-            <a:r>
-              <a:rPr sz="1100" b="0" i="0">
+              <a:t>Online, asynchronous, self-paced (~15 min)</a:t>
+            </a:r>
+          </a:p>
+          <a:p>
+            <a:pPr algn="l"/>
+            <a:r>
+              <a:rPr sz="1100" b="0" i="0" dirty="0">
                 <a:solidFill>
                   <a:srgbClr val="1A2B3C"/>
                 </a:solidFill>
@@ -4373,7 +4567,7 @@
           </a:p>
           <a:p>
             <a:pPr algn="l"/>
-            <a:endParaRPr sz="1100" b="0" i="0">
+            <a:endParaRPr sz="1100" b="0" i="0" dirty="0">
               <a:solidFill>
                 <a:srgbClr val="1A2B3C"/>
               </a:solidFill>
@@ -4382,18 +4576,34 @@
           <a:p>
             <a:pPr algn="l"/>
             <a:r>
-              <a:rPr sz="1200" b="1" i="0">
+              <a:rPr sz="1200" b="1" i="0" dirty="0">
                 <a:solidFill>
                   <a:srgbClr val="02C39A"/>
                 </a:solidFill>
               </a:rPr>
-              <a:t>1  Pre-test (Form A)</a:t>
-            </a:r>
-          </a:p>
-          <a:p>
-            <a:pPr algn="l"/>
-            <a:r>
-              <a:rPr sz="1000" b="0" i="0">
+              <a:t>1</a:t>
+            </a:r>
+            <a:r>
+              <a:rPr lang="en-US" sz="1200" b="1" i="0" dirty="0">
+                <a:solidFill>
+                  <a:srgbClr val="02C39A"/>
+                </a:solidFill>
+              </a:rPr>
+              <a:t>.</a:t>
+            </a:r>
+            <a:r>
+              <a:rPr sz="1200" b="1" i="0" dirty="0">
+                <a:solidFill>
+                  <a:srgbClr val="02C39A"/>
+                </a:solidFill>
+              </a:rPr>
+              <a:t>  Pre-test (Form A)</a:t>
+            </a:r>
+          </a:p>
+          <a:p>
+            <a:pPr algn="l"/>
+            <a:r>
+              <a:rPr sz="1000" b="0" i="0" dirty="0">
                 <a:solidFill>
                   <a:srgbClr val="1A2B3C"/>
                 </a:solidFill>
@@ -4403,18 +4613,7 @@
           </a:p>
           <a:p>
             <a:pPr algn="l"/>
-            <a:r>
-              <a:rPr sz="1000" b="0" i="0">
-                <a:solidFill>
-                  <a:srgbClr val="5A7A8A"/>
-                </a:solidFill>
-              </a:rPr>
-              <a:t>Speakers: Female Voice 1 + Male Voice 1</a:t>
-            </a:r>
-          </a:p>
-          <a:p>
-            <a:pPr algn="l"/>
-            <a:endParaRPr sz="1000" b="0" i="0">
+            <a:endParaRPr sz="1000" b="0" i="0" dirty="0">
               <a:solidFill>
                 <a:srgbClr val="5A7A8A"/>
               </a:solidFill>
@@ -4423,18 +4622,34 @@
           <a:p>
             <a:pPr algn="l"/>
             <a:r>
-              <a:rPr sz="1200" b="1" i="0">
+              <a:rPr sz="1200" b="1" i="0" dirty="0">
                 <a:solidFill>
                   <a:srgbClr val="2196F3"/>
                 </a:solidFill>
               </a:rPr>
-              <a:t>2  Practice with the App</a:t>
-            </a:r>
-          </a:p>
-          <a:p>
-            <a:pPr algn="l"/>
-            <a:r>
-              <a:rPr sz="1000" b="0" i="0">
+              <a:t>2</a:t>
+            </a:r>
+            <a:r>
+              <a:rPr lang="en-US" sz="1200" b="1" i="0" dirty="0">
+                <a:solidFill>
+                  <a:srgbClr val="2196F3"/>
+                </a:solidFill>
+              </a:rPr>
+              <a:t>.</a:t>
+            </a:r>
+            <a:r>
+              <a:rPr sz="1200" b="1" i="0" dirty="0">
+                <a:solidFill>
+                  <a:srgbClr val="2196F3"/>
+                </a:solidFill>
+              </a:rPr>
+              <a:t>  Practice with the App</a:t>
+            </a:r>
+          </a:p>
+          <a:p>
+            <a:pPr algn="l"/>
+            <a:r>
+              <a:rPr sz="1000" b="0" i="0" dirty="0">
                 <a:solidFill>
                   <a:srgbClr val="1A2B3C"/>
                 </a:solidFill>
@@ -4445,7 +4660,7 @@
           <a:p>
             <a:pPr algn="l"/>
             <a:r>
-              <a:rPr sz="1000" b="0" i="0">
+              <a:rPr sz="1000" b="0" i="0" dirty="0">
                 <a:solidFill>
                   <a:srgbClr val="5A7A8A"/>
                 </a:solidFill>
@@ -4455,7 +4670,7 @@
           </a:p>
           <a:p>
             <a:pPr algn="l"/>
-            <a:endParaRPr sz="1000" b="0" i="0">
+            <a:endParaRPr sz="1000" b="0" i="0" dirty="0">
               <a:solidFill>
                 <a:srgbClr val="5A7A8A"/>
               </a:solidFill>
@@ -4464,39 +4679,49 @@
           <a:p>
             <a:pPr algn="l"/>
             <a:r>
-              <a:rPr sz="1200" b="1" i="0">
+              <a:rPr sz="1200" b="1" i="0" dirty="0">
                 <a:solidFill>
                   <a:srgbClr val="4CAF50"/>
                 </a:solidFill>
               </a:rPr>
-              <a:t>3  Post-test (Form B)</a:t>
-            </a:r>
-          </a:p>
-          <a:p>
-            <a:pPr algn="l"/>
-            <a:r>
-              <a:rPr sz="1000" b="0" i="0">
+              <a:t>3</a:t>
+            </a:r>
+            <a:r>
+              <a:rPr lang="en-US" sz="1200" b="1" i="0" dirty="0">
+                <a:solidFill>
+                  <a:srgbClr val="4CAF50"/>
+                </a:solidFill>
+              </a:rPr>
+              <a:t>.</a:t>
+            </a:r>
+            <a:r>
+              <a:rPr sz="1200" b="1" i="0" dirty="0">
+                <a:solidFill>
+                  <a:srgbClr val="4CAF50"/>
+                </a:solidFill>
+              </a:rPr>
+              <a:t>  Post-test (Form B)</a:t>
+            </a:r>
+          </a:p>
+          <a:p>
+            <a:pPr algn="l"/>
+            <a:r>
+              <a:rPr sz="1000" b="0" i="0" dirty="0">
                 <a:solidFill>
                   <a:srgbClr val="1A2B3C"/>
                 </a:solidFill>
               </a:rPr>
-              <a:t>12 new clips · different speakers (Female Voice 2 + Male Voice 2)</a:t>
-            </a:r>
-          </a:p>
-          <a:p>
-            <a:pPr algn="l"/>
-            <a:r>
-              <a:rPr sz="1000" b="0" i="0">
-                <a:solidFill>
-                  <a:srgbClr val="5A7A8A"/>
-                </a:solidFill>
-              </a:rPr>
-              <a:t>Same format, counterbalanced to minimise item-overlap confound</a:t>
-            </a:r>
-          </a:p>
-          <a:p>
-            <a:pPr algn="l"/>
-            <a:endParaRPr sz="1000" b="0" i="0">
+              <a:t>12 new clips · different speakers </a:t>
+            </a:r>
+            <a:endParaRPr lang="en-US" sz="1000" b="0" i="0" dirty="0">
+              <a:solidFill>
+                <a:srgbClr val="1A2B3C"/>
+              </a:solidFill>
+            </a:endParaRPr>
+          </a:p>
+          <a:p>
+            <a:pPr algn="l"/>
+            <a:endParaRPr sz="1000" b="0" i="0" dirty="0">
               <a:solidFill>
                 <a:srgbClr val="5A7A8A"/>
               </a:solidFill>
@@ -4505,18 +4730,34 @@
           <a:p>
             <a:pPr algn="l"/>
             <a:r>
-              <a:rPr sz="1200" b="1" i="0">
+              <a:rPr sz="1200" b="1" i="0" dirty="0">
                 <a:solidFill>
                   <a:srgbClr val="FF9800"/>
                 </a:solidFill>
               </a:rPr>
-              <a:t>4  TAM Usability Survey</a:t>
-            </a:r>
-          </a:p>
-          <a:p>
-            <a:pPr algn="l"/>
-            <a:r>
-              <a:rPr sz="1000" b="0" i="0">
+              <a:t>4</a:t>
+            </a:r>
+            <a:r>
+              <a:rPr lang="en-US" sz="1200" b="1" i="0" dirty="0">
+                <a:solidFill>
+                  <a:srgbClr val="FF9800"/>
+                </a:solidFill>
+              </a:rPr>
+              <a:t>.</a:t>
+            </a:r>
+            <a:r>
+              <a:rPr sz="1200" b="1" i="0" dirty="0">
+                <a:solidFill>
+                  <a:srgbClr val="FF9800"/>
+                </a:solidFill>
+              </a:rPr>
+              <a:t>  TAM Usability Survey</a:t>
+            </a:r>
+          </a:p>
+          <a:p>
+            <a:pPr algn="l"/>
+            <a:r>
+              <a:rPr sz="1000" b="0" i="0" dirty="0">
                 <a:solidFill>
                   <a:srgbClr val="1A2B3C"/>
                 </a:solidFill>
@@ -4631,12 +4872,12 @@
           <a:noFill/>
         </p:spPr>
         <p:txBody>
-          <a:bodyPr wrap="square"/>
-          <a:lstStyle/>
-          <a:p>
-            <a:pPr algn="l"/>
-            <a:r>
-              <a:rPr sz="1400" b="1" i="0">
+          <a:bodyPr wrap="square" anchor="ctr"/>
+          <a:lstStyle/>
+          <a:p>
+            <a:pPr algn="l"/>
+            <a:r>
+              <a:rPr sz="1400" b="1" i="0" dirty="0">
                 <a:solidFill>
                   <a:srgbClr val="FFFFFF"/>
                 </a:solidFill>
@@ -4654,8 +4895,8 @@
         </p:nvSpPr>
         <p:spPr>
           <a:xfrm>
-            <a:off x="4846320" y="1463040"/>
-            <a:ext cx="3840480" cy="3223260"/>
+            <a:off x="4846320" y="1371600"/>
+            <a:ext cx="3840480" cy="3451860"/>
           </a:xfrm>
           <a:prstGeom prst="rect">
             <a:avLst/>
@@ -4668,7 +4909,7 @@
           <a:p>
             <a:pPr algn="l"/>
             <a:r>
-              <a:rPr sz="1200" b="1" i="0">
+              <a:rPr sz="1200" b="1" i="0" dirty="0">
                 <a:solidFill>
                   <a:srgbClr val="065A82"/>
                 </a:solidFill>
@@ -4679,7 +4920,7 @@
           <a:p>
             <a:pPr algn="l"/>
             <a:r>
-              <a:rPr sz="1100" b="0" i="0">
+              <a:rPr sz="1100" b="0" i="0" dirty="0">
                 <a:solidFill>
                   <a:srgbClr val="1A2B3C"/>
                 </a:solidFill>
@@ -4690,39 +4931,60 @@
           <a:p>
             <a:pPr algn="l"/>
             <a:r>
-              <a:rPr sz="1100" b="0" i="0">
+              <a:rPr sz="1100" b="0" i="0" dirty="0">
                 <a:solidFill>
                   <a:srgbClr val="1A2B3C"/>
                 </a:solidFill>
               </a:rPr>
-              <a:t>• Items randomised per participant (seeded by participant ID)</a:t>
-            </a:r>
-          </a:p>
-          <a:p>
-            <a:pPr algn="l"/>
-            <a:r>
-              <a:rPr sz="1100" b="0" i="0">
+              <a:t>• Items randomi</a:t>
+            </a:r>
+            <a:r>
+              <a:rPr lang="en-US" sz="1100" b="0" i="0" dirty="0">
                 <a:solidFill>
                   <a:srgbClr val="1A2B3C"/>
                 </a:solidFill>
               </a:rPr>
+              <a:t>z</a:t>
+            </a:r>
+            <a:r>
+              <a:rPr sz="1100" b="0" i="0" dirty="0">
+                <a:solidFill>
+                  <a:srgbClr val="1A2B3C"/>
+                </a:solidFill>
+              </a:rPr>
+              <a:t>ed per participant (seeded by participant ID)</a:t>
+            </a:r>
+          </a:p>
+          <a:p>
+            <a:pPr algn="l"/>
+            <a:r>
+              <a:rPr sz="1100" b="0" i="0" dirty="0">
+                <a:solidFill>
+                  <a:srgbClr val="1A2B3C"/>
+                </a:solidFill>
+              </a:rPr>
               <a:t>• Scored: proportion correct (0–12 per participant)</a:t>
             </a:r>
           </a:p>
           <a:p>
             <a:pPr algn="l"/>
             <a:r>
-              <a:rPr sz="1100" b="0" i="0">
+              <a:rPr sz="1100" b="0" i="0" dirty="0">
                 <a:solidFill>
                   <a:srgbClr val="1A2B3C"/>
                 </a:solidFill>
               </a:rPr>
-              <a:t>• Responses stored in Google Sheets via gspread</a:t>
-            </a:r>
-          </a:p>
-          <a:p>
-            <a:pPr algn="l"/>
-            <a:endParaRPr sz="1100" b="0" i="0">
+              <a:t>• Responses stored in Google Sheets via </a:t>
+            </a:r>
+            <a:r>
+              <a:rPr sz="1100" b="0" i="0" dirty="0" err="1">
+                <a:solidFill>
+                  <a:srgbClr val="1A2B3C"/>
+                </a:solidFill>
+              </a:rPr>
+              <a:t>gspread</a:t>
+            </a:r>
+            <a:endParaRPr sz="1100" b="0" i="0" dirty="0">
               <a:solidFill>
                 <a:srgbClr val="1A2B3C"/>
               </a:solidFill>
@@ -4730,40 +4992,7 @@
           </a:p>
           <a:p>
             <a:pPr algn="l"/>
-            <a:r>
-              <a:rPr sz="1200" b="1" i="0">
-                <a:solidFill>
-                  <a:srgbClr val="065A82"/>
-                </a:solidFill>
-              </a:rPr>
-              <a:t>Speaker Design</a:t>
-            </a:r>
-          </a:p>
-          <a:p>
-            <a:pPr algn="l"/>
-            <a:r>
-              <a:rPr sz="1100" b="0" i="0">
-                <a:solidFill>
-                  <a:srgbClr val="1A2B3C"/>
-                </a:solidFill>
-              </a:rPr>
-              <a:t>• Form A — Female Voice 1 &amp; Male Voice 1</a:t>
-            </a:r>
-          </a:p>
-          <a:p>
-            <a:pPr algn="l"/>
-            <a:r>
-              <a:rPr sz="1100" b="0" i="0">
-                <a:solidFill>
-                  <a:srgbClr val="1A2B3C"/>
-                </a:solidFill>
-              </a:rPr>
-              <a:t>• Form B — Female Voice 2 &amp; Male Voice 2  (new, unseen speakers)</a:t>
-            </a:r>
-          </a:p>
-          <a:p>
-            <a:pPr algn="l"/>
-            <a:endParaRPr sz="1100" b="0" i="0">
+            <a:endParaRPr sz="1100" b="0" i="0" dirty="0">
               <a:solidFill>
                 <a:srgbClr val="1A2B3C"/>
               </a:solidFill>
@@ -4772,50 +5001,39 @@
           <a:p>
             <a:pPr algn="l"/>
             <a:r>
-              <a:rPr sz="1200" b="1" i="0">
+              <a:rPr sz="1200" b="1" i="0" dirty="0">
                 <a:solidFill>
                   <a:srgbClr val="065A82"/>
                 </a:solidFill>
               </a:rPr>
-              <a:t>TAM Survey  (Technology Acceptance Model)</a:t>
-            </a:r>
-          </a:p>
-          <a:p>
-            <a:pPr algn="l"/>
-            <a:r>
-              <a:rPr sz="1100" b="0" i="0">
+              <a:t>Speaker Design</a:t>
+            </a:r>
+          </a:p>
+          <a:p>
+            <a:pPr algn="l"/>
+            <a:r>
+              <a:rPr sz="1100" b="0" i="0" dirty="0">
                 <a:solidFill>
                   <a:srgbClr val="1A2B3C"/>
                 </a:solidFill>
               </a:rPr>
-              <a:t>• 8 Likert items, 5-point scale (1 = strongly disagree → 5 = strongly agree)</a:t>
-            </a:r>
-          </a:p>
-          <a:p>
-            <a:pPr algn="l"/>
-            <a:r>
-              <a:rPr sz="1100" b="0" i="0">
+              <a:t>• Form A — Female Voice 1 &amp; Male Voice 1</a:t>
+            </a:r>
+          </a:p>
+          <a:p>
+            <a:pPr algn="l"/>
+            <a:r>
+              <a:rPr sz="1100" b="0" i="0" dirty="0">
                 <a:solidFill>
                   <a:srgbClr val="1A2B3C"/>
                 </a:solidFill>
               </a:rPr>
-              <a:t>• Constructs: perceived usefulness, ease of use, reuse intent</a:t>
-            </a:r>
-          </a:p>
-          <a:p>
-            <a:pPr algn="l"/>
-            <a:r>
-              <a:rPr sz="1100" b="0" i="0">
-                <a:solidFill>
-                  <a:srgbClr val="1A2B3C"/>
-                </a:solidFill>
-              </a:rPr>
-              <a:t>• 1 open-ended question for qualitative feedback</a:t>
-            </a:r>
-          </a:p>
-          <a:p>
-            <a:pPr algn="l"/>
-            <a:endParaRPr sz="1100" b="0" i="0">
+              <a:t>• Form B — Female Voice 2 &amp; Male Voice 2  (new, unseen speakers)</a:t>
+            </a:r>
+          </a:p>
+          <a:p>
+            <a:pPr algn="l"/>
+            <a:endParaRPr sz="1100" b="0" i="0" dirty="0">
               <a:solidFill>
                 <a:srgbClr val="1A2B3C"/>
               </a:solidFill>
@@ -4824,18 +5042,70 @@
           <a:p>
             <a:pPr algn="l"/>
             <a:r>
-              <a:rPr sz="1200" b="1" i="0">
+              <a:rPr sz="1200" b="1" i="0" dirty="0">
                 <a:solidFill>
                   <a:srgbClr val="065A82"/>
                 </a:solidFill>
               </a:rPr>
+              <a:t>TAM Survey  (Technology Acceptance Model)</a:t>
+            </a:r>
+          </a:p>
+          <a:p>
+            <a:pPr algn="l"/>
+            <a:r>
+              <a:rPr sz="1100" b="0" i="0" dirty="0">
+                <a:solidFill>
+                  <a:srgbClr val="1A2B3C"/>
+                </a:solidFill>
+              </a:rPr>
+              <a:t>• 8 Likert items, 5-point scale (1 = strongly disagree → 5 = strongly agree)</a:t>
+            </a:r>
+          </a:p>
+          <a:p>
+            <a:pPr algn="l"/>
+            <a:r>
+              <a:rPr sz="1100" b="0" i="0" dirty="0">
+                <a:solidFill>
+                  <a:srgbClr val="1A2B3C"/>
+                </a:solidFill>
+              </a:rPr>
+              <a:t>• Constructs: perceived usefulness, ease of use, reuse intent</a:t>
+            </a:r>
+          </a:p>
+          <a:p>
+            <a:pPr algn="l"/>
+            <a:r>
+              <a:rPr sz="1100" b="0" i="0" dirty="0">
+                <a:solidFill>
+                  <a:srgbClr val="1A2B3C"/>
+                </a:solidFill>
+              </a:rPr>
+              <a:t>• 1 open-ended question for qualitative feedback</a:t>
+            </a:r>
+          </a:p>
+          <a:p>
+            <a:pPr algn="l"/>
+            <a:endParaRPr sz="1100" b="0" i="0" dirty="0">
+              <a:solidFill>
+                <a:srgbClr val="1A2B3C"/>
+              </a:solidFill>
+            </a:endParaRPr>
+          </a:p>
+          <a:p>
+            <a:pPr algn="l"/>
+            <a:r>
+              <a:rPr sz="1200" b="1" i="0" dirty="0">
+                <a:solidFill>
+                  <a:srgbClr val="065A82"/>
+                </a:solidFill>
+              </a:rPr>
               <a:t>Participant IDs</a:t>
             </a:r>
           </a:p>
           <a:p>
             <a:pPr algn="l"/>
             <a:r>
-              <a:rPr sz="1100" b="0" i="0">
+              <a:rPr sz="1100" b="0" i="0" dirty="0">
                 <a:solidFill>
                   <a:srgbClr val="1A2B3C"/>
                 </a:solidFill>
@@ -4846,7 +5116,7 @@
           <a:p>
             <a:pPr algn="l"/>
             <a:r>
-              <a:rPr sz="1100" b="0" i="0">
+              <a:rPr sz="1100" b="0" i="0" dirty="0">
                 <a:solidFill>
                   <a:srgbClr val="1A2B3C"/>
                 </a:solidFill>
@@ -4942,17 +5212,17 @@
           <a:noFill/>
         </p:spPr>
         <p:txBody>
-          <a:bodyPr wrap="square"/>
-          <a:lstStyle/>
-          <a:p>
-            <a:pPr algn="l"/>
-            <a:r>
-              <a:rPr sz="2000" b="1" i="0">
+          <a:bodyPr wrap="square" anchor="ctr"/>
+          <a:lstStyle/>
+          <a:p>
+            <a:pPr algn="l"/>
+            <a:r>
+              <a:rPr sz="2600" b="1" i="0" dirty="0">
                 <a:solidFill>
                   <a:srgbClr val="FFFFFF"/>
                 </a:solidFill>
               </a:rPr>
-              <a:t>Participant Demographics  —  19 Perception Test · 16 TAM Survey Respondents</a:t>
+              <a:t>Participant Demographics</a:t>
             </a:r>
           </a:p>
         </p:txBody>
@@ -4965,8 +5235,8 @@
         </p:nvSpPr>
         <p:spPr>
           <a:xfrm>
-            <a:off x="274320" y="960120"/>
-            <a:ext cx="2743200" cy="4000500"/>
+            <a:off x="274320" y="960119"/>
+            <a:ext cx="2743200" cy="4000499"/>
           </a:xfrm>
           <a:prstGeom prst="rect">
             <a:avLst/>
@@ -5009,7 +5279,7 @@
         </p:nvSpPr>
         <p:spPr>
           <a:xfrm>
-            <a:off x="274320" y="1234440"/>
+            <a:off x="274320" y="1355636"/>
             <a:ext cx="2743200" cy="600000"/>
           </a:xfrm>
           <a:prstGeom prst="rect">
@@ -5023,7 +5293,7 @@
           <a:p>
             <a:pPr algn="ctr"/>
             <a:r>
-              <a:rPr sz="5200" b="1" i="0">
+              <a:rPr sz="4000" b="1" i="0" dirty="0">
                 <a:solidFill>
                   <a:srgbClr val="02C39A"/>
                 </a:solidFill>
@@ -5041,7 +5311,7 @@
         </p:nvSpPr>
         <p:spPr>
           <a:xfrm>
-            <a:off x="274320" y="1814440"/>
+            <a:off x="274320" y="1907679"/>
             <a:ext cx="2743200" cy="280000"/>
           </a:xfrm>
           <a:prstGeom prst="rect">
@@ -5055,7 +5325,7 @@
           <a:p>
             <a:pPr algn="ctr"/>
             <a:r>
-              <a:rPr sz="1400" b="0" i="0">
+              <a:rPr sz="1400" b="0" i="0" dirty="0">
                 <a:solidFill>
                   <a:srgbClr val="CADCFC"/>
                 </a:solidFill>
@@ -5073,7 +5343,7 @@
         </p:nvSpPr>
         <p:spPr>
           <a:xfrm>
-            <a:off x="457200" y="2114440"/>
+            <a:off x="457200" y="2258035"/>
             <a:ext cx="2377440" cy="36576"/>
           </a:xfrm>
           <a:prstGeom prst="rect">
@@ -5111,104 +5381,13 @@
       </p:sp>
       <p:sp>
         <p:nvSpPr>
-          <p:cNvPr id="8" name="TextBox 7"/>
-          <p:cNvSpPr txBox="1"/>
-          <p:nvPr/>
-        </p:nvSpPr>
-        <p:spPr>
-          <a:xfrm>
-            <a:off x="365760" y="2194440"/>
-            <a:ext cx="2560320" cy="400000"/>
-          </a:xfrm>
-          <a:prstGeom prst="rect">
-            <a:avLst/>
-          </a:prstGeom>
-          <a:noFill/>
-        </p:spPr>
-        <p:txBody>
-          <a:bodyPr wrap="square"/>
-          <a:lstStyle/>
-          <a:p>
-            <a:pPr algn="ctr"/>
-            <a:r>
-              <a:rPr sz="1200" b="0" i="0">
-                <a:solidFill>
-                  <a:srgbClr val="CADCFC"/>
-                </a:solidFill>
-              </a:rPr>
-              <a:t>13 paired (both forms)</a:t>
-            </a:r>
-          </a:p>
-          <a:p>
-            <a:pPr algn="ctr">
-              <a:spcBef>
-                <a:spcPts val="600"/>
-              </a:spcBef>
-            </a:pPr>
-            <a:r>
-              <a:rPr sz="1100" b="0" i="0">
-                <a:solidFill>
-                  <a:srgbClr val="5A7A8A"/>
-                </a:solidFill>
-              </a:rPr>
-              <a:t>6 Form A only</a:t>
-            </a:r>
-          </a:p>
-        </p:txBody>
-      </p:sp>
-      <p:sp>
-        <p:nvSpPr>
-          <p:cNvPr id="9" name="Rectangle 8"/>
-          <p:cNvSpPr/>
-          <p:nvPr/>
-        </p:nvSpPr>
-        <p:spPr>
-          <a:xfrm>
-            <a:off x="457200" y="2644440"/>
-            <a:ext cx="2377440" cy="36576"/>
-          </a:xfrm>
-          <a:prstGeom prst="rect">
-            <a:avLst/>
-          </a:prstGeom>
-          <a:solidFill>
-            <a:srgbClr val="1C7293"/>
-          </a:solidFill>
-          <a:ln>
-            <a:noFill/>
-          </a:ln>
-        </p:spPr>
-        <p:style>
-          <a:lnRef idx="1">
-            <a:schemeClr val="accent1"/>
-          </a:lnRef>
-          <a:fillRef idx="3">
-            <a:schemeClr val="accent1"/>
-          </a:fillRef>
-          <a:effectRef idx="2">
-            <a:schemeClr val="accent1"/>
-          </a:effectRef>
-          <a:fontRef idx="minor">
-            <a:schemeClr val="lt1"/>
-          </a:fontRef>
-        </p:style>
-        <p:txBody>
-          <a:bodyPr rtlCol="0" anchor="ctr"/>
-          <a:lstStyle/>
-          <a:p>
-            <a:pPr algn="ctr"/>
-            <a:endParaRPr/>
-          </a:p>
-        </p:txBody>
-      </p:sp>
-      <p:sp>
-        <p:nvSpPr>
           <p:cNvPr id="10" name="TextBox 9"/>
           <p:cNvSpPr txBox="1"/>
           <p:nvPr/>
         </p:nvSpPr>
         <p:spPr>
           <a:xfrm>
-            <a:off x="274320" y="2724440"/>
+            <a:off x="274320" y="2221090"/>
             <a:ext cx="2743200" cy="500000"/>
           </a:xfrm>
           <a:prstGeom prst="rect">
@@ -5222,7 +5401,7 @@
           <a:p>
             <a:pPr algn="ctr"/>
             <a:r>
-              <a:rPr sz="4000" b="1" i="0">
+              <a:rPr sz="4000" b="1" i="0" dirty="0">
                 <a:solidFill>
                   <a:srgbClr val="02C39A"/>
                 </a:solidFill>
@@ -5240,8 +5419,8 @@
         </p:nvSpPr>
         <p:spPr>
           <a:xfrm>
-            <a:off x="365760" y="3204440"/>
-            <a:ext cx="2560320" cy="300000"/>
+            <a:off x="457200" y="2777490"/>
+            <a:ext cx="2377440" cy="300000"/>
           </a:xfrm>
           <a:prstGeom prst="rect">
             <a:avLst/>
@@ -5254,7 +5433,7 @@
           <a:p>
             <a:pPr algn="ctr"/>
             <a:r>
-              <a:rPr sz="1200" b="0" i="0">
+              <a:rPr sz="1200" b="0" i="0" dirty="0">
                 <a:solidFill>
                   <a:srgbClr val="CADCFC"/>
                 </a:solidFill>
@@ -5369,12 +5548,12 @@
           <a:noFill/>
         </p:spPr>
         <p:txBody>
-          <a:bodyPr wrap="square"/>
-          <a:lstStyle/>
-          <a:p>
-            <a:pPr algn="l"/>
-            <a:r>
-              <a:rPr sz="1300" b="1" i="0">
+          <a:bodyPr wrap="square" anchor="ctr"/>
+          <a:lstStyle/>
+          <a:p>
+            <a:pPr algn="l"/>
+            <a:r>
+              <a:rPr sz="1300" b="1" i="0" dirty="0">
                 <a:solidFill>
                   <a:srgbClr val="FFFFFF"/>
                 </a:solidFill>
@@ -5570,12 +5749,12 @@
           <a:noFill/>
         </p:spPr>
         <p:txBody>
-          <a:bodyPr wrap="square"/>
-          <a:lstStyle/>
-          <a:p>
-            <a:pPr algn="l"/>
-            <a:r>
-              <a:rPr sz="1300" b="1" i="0">
+          <a:bodyPr wrap="square" anchor="ctr"/>
+          <a:lstStyle/>
+          <a:p>
+            <a:pPr algn="l"/>
+            <a:r>
+              <a:rPr sz="1300" b="1" i="0" dirty="0">
                 <a:solidFill>
                   <a:srgbClr val="FFFFFF"/>
                 </a:solidFill>
@@ -5812,17 +5991,17 @@
           <a:noFill/>
         </p:spPr>
         <p:txBody>
-          <a:bodyPr wrap="square"/>
-          <a:lstStyle/>
-          <a:p>
-            <a:pPr algn="l"/>
-            <a:r>
-              <a:rPr sz="2000" b="1" i="0">
+          <a:bodyPr wrap="square" anchor="ctr"/>
+          <a:lstStyle/>
+          <a:p>
+            <a:pPr algn="l"/>
+            <a:r>
+              <a:rPr sz="2600" b="1" i="0" dirty="0">
                 <a:solidFill>
                   <a:srgbClr val="FFFFFF"/>
                 </a:solidFill>
               </a:rPr>
-              <a:t>Pre/Post Perception Test Results  —  13 Paired Participants</a:t>
+              <a:t>Pre/Post Perception Test Results</a:t>
             </a:r>
           </a:p>
         </p:txBody>
@@ -6063,7 +6242,7 @@
         </p:nvSpPr>
         <p:spPr>
           <a:xfrm>
-            <a:off x="457200" y="2697320"/>
+            <a:off x="457200" y="2547320"/>
             <a:ext cx="2034240" cy="280000"/>
           </a:xfrm>
           <a:prstGeom prst="rect">
@@ -6077,7 +6256,7 @@
           <a:p>
             <a:pPr algn="l"/>
             <a:r>
-              <a:rPr sz="1200" b="1" i="0">
+              <a:rPr sz="1200" b="1" i="0" dirty="0">
                 <a:solidFill>
                   <a:srgbClr val="02C39A"/>
                 </a:solidFill>
@@ -6095,7 +6274,7 @@
         </p:nvSpPr>
         <p:spPr>
           <a:xfrm>
-            <a:off x="457200" y="2997320"/>
+            <a:off x="457200" y="2765880"/>
             <a:ext cx="2034240" cy="1760420"/>
           </a:xfrm>
           <a:prstGeom prst="rect">
@@ -6109,7 +6288,7 @@
           <a:p>
             <a:pPr algn="l"/>
             <a:r>
-              <a:rPr sz="1000" b="1" i="0">
+              <a:rPr sz="1000" b="1" i="0" dirty="0">
                 <a:solidFill>
                   <a:srgbClr val="CADCFC"/>
                 </a:solidFill>
@@ -6120,17 +6299,20 @@
           <a:p>
             <a:pPr algn="l"/>
             <a:r>
-              <a:rPr sz="1000" b="0" i="0">
+              <a:rPr sz="1000" b="0" i="0" dirty="0">
                 <a:solidFill>
                   <a:srgbClr val="1A2B3C"/>
                 </a:solidFill>
+                <a:highlight>
+                  <a:srgbClr val="FFFF00"/>
+                </a:highlight>
               </a:rPr>
               <a:t>W = 13.5,  p = 0.087 (two-sided)</a:t>
             </a:r>
           </a:p>
           <a:p>
             <a:pPr algn="l"/>
-            <a:endParaRPr sz="1000" b="0" i="0">
+            <a:endParaRPr sz="1000" b="0" i="0" dirty="0">
               <a:solidFill>
                 <a:srgbClr val="1A2B3C"/>
               </a:solidFill>
@@ -6139,7 +6321,7 @@
           <a:p>
             <a:pPr algn="l"/>
             <a:r>
-              <a:rPr sz="1000" b="1" i="0">
+              <a:rPr sz="1000" b="1" i="0" dirty="0">
                 <a:solidFill>
                   <a:srgbClr val="CADCFC"/>
                 </a:solidFill>
@@ -6150,17 +6332,20 @@
           <a:p>
             <a:pPr algn="l"/>
             <a:r>
-              <a:rPr sz="1000" b="0" i="0">
+              <a:rPr sz="1000" b="0" i="0" dirty="0">
                 <a:solidFill>
                   <a:srgbClr val="1A2B3C"/>
                 </a:solidFill>
+                <a:highlight>
+                  <a:srgbClr val="FFFF00"/>
+                </a:highlight>
               </a:rPr>
               <a:t>t = −2.17,  p = 0.051</a:t>
             </a:r>
           </a:p>
           <a:p>
             <a:pPr algn="l"/>
-            <a:endParaRPr sz="1000" b="0" i="0">
+            <a:endParaRPr sz="1000" b="0" i="0" dirty="0">
               <a:solidFill>
                 <a:srgbClr val="1A2B3C"/>
               </a:solidFill>
@@ -6169,7 +6354,7 @@
           <a:p>
             <a:pPr algn="l"/>
             <a:r>
-              <a:rPr sz="1000" b="1" i="0">
+              <a:rPr sz="1000" b="1" i="0" dirty="0">
                 <a:solidFill>
                   <a:srgbClr val="CADCFC"/>
                 </a:solidFill>
@@ -6180,17 +6365,20 @@
           <a:p>
             <a:pPr algn="l"/>
             <a:r>
-              <a:rPr sz="1000" b="0" i="0">
+              <a:rPr sz="1000" b="0" i="0" dirty="0">
                 <a:solidFill>
                   <a:srgbClr val="1A2B3C"/>
                 </a:solidFill>
+                <a:highlight>
+                  <a:srgbClr val="FFFF00"/>
+                </a:highlight>
               </a:rPr>
               <a:t>3 items per tone per participant</a:t>
             </a:r>
           </a:p>
           <a:p>
             <a:pPr algn="l"/>
-            <a:endParaRPr sz="1000" b="0" i="0">
+            <a:endParaRPr sz="1000" b="0" i="0" dirty="0">
               <a:solidFill>
                 <a:srgbClr val="1A2B3C"/>
               </a:solidFill>
@@ -6199,7 +6387,7 @@
           <a:p>
             <a:pPr algn="l"/>
             <a:r>
-              <a:rPr sz="1000" b="1" i="0">
+              <a:rPr sz="1000" b="1" i="0" dirty="0">
                 <a:solidFill>
                   <a:srgbClr val="CADCFC"/>
                 </a:solidFill>
@@ -6210,10 +6398,13 @@
           <a:p>
             <a:pPr algn="l"/>
             <a:r>
-              <a:rPr sz="1000" b="0" i="0">
+              <a:rPr sz="1000" b="0" i="0" dirty="0">
                 <a:solidFill>
                   <a:srgbClr val="1A2B3C"/>
                 </a:solidFill>
+                <a:highlight>
+                  <a:srgbClr val="FFFF00"/>
+                </a:highlight>
               </a:rPr>
               <a:t>Strong positive trend; p just above 0.05 threshold — marginal with n=13 (est. power ~35%)</a:t>
             </a:r>
@@ -6330,17 +6521,17 @@
           <a:noFill/>
         </p:spPr>
         <p:txBody>
-          <a:bodyPr wrap="square"/>
-          <a:lstStyle/>
-          <a:p>
-            <a:pPr algn="l"/>
-            <a:r>
-              <a:rPr sz="2000" b="1" i="0">
+          <a:bodyPr wrap="square" anchor="ctr"/>
+          <a:lstStyle/>
+          <a:p>
+            <a:pPr algn="l"/>
+            <a:r>
+              <a:rPr sz="2600" b="1" i="0" dirty="0">
                 <a:solidFill>
                   <a:srgbClr val="FFFFFF"/>
                 </a:solidFill>
               </a:rPr>
-              <a:t>Per-Tone Accuracy  —  Pre vs Post  (13 paired participants, 3 items / tone each)</a:t>
+              <a:t>Per-Tone Accuracy</a:t>
             </a:r>
           </a:p>
         </p:txBody>
@@ -6450,12 +6641,12 @@
           <a:noFill/>
         </p:spPr>
         <p:txBody>
-          <a:bodyPr wrap="square"/>
+          <a:bodyPr wrap="square" anchor="ctr"/>
           <a:lstStyle/>
           <a:p>
             <a:pPr algn="ctr"/>
             <a:r>
-              <a:rPr sz="1300" b="1" i="0">
+              <a:rPr sz="1300" b="1" i="0" dirty="0">
                 <a:solidFill>
                   <a:srgbClr val="FFFFFF"/>
                 </a:solidFill>
@@ -6487,7 +6678,7 @@
           <a:p>
             <a:pPr algn="l"/>
             <a:r>
-              <a:rPr sz="1000" b="0" i="0">
+              <a:rPr sz="1000" b="0" i="0" dirty="0">
                 <a:solidFill>
                   <a:srgbClr val="5A7A8A"/>
                 </a:solidFill>
@@ -6502,7 +6693,7 @@
               </a:spcBef>
             </a:pPr>
             <a:r>
-              <a:rPr sz="1400" b="1" i="0">
+              <a:rPr sz="1400" b="1" i="0" dirty="0">
                 <a:solidFill>
                   <a:srgbClr val="2196F3"/>
                 </a:solidFill>
@@ -6512,7 +6703,7 @@
           </a:p>
           <a:p>
             <a:pPr algn="l"/>
-            <a:endParaRPr sz="1400" b="1" i="0">
+            <a:endParaRPr sz="1400" b="1" i="0" dirty="0">
               <a:solidFill>
                 <a:srgbClr val="2196F3"/>
               </a:solidFill>
@@ -6521,7 +6712,7 @@
           <a:p>
             <a:pPr algn="l"/>
             <a:r>
-              <a:rPr sz="1000" b="1" i="0">
+              <a:rPr sz="1000" b="1" i="0" dirty="0">
                 <a:solidFill>
                   <a:srgbClr val="1A2B3C"/>
                 </a:solidFill>
@@ -6536,7 +6727,7 @@
               </a:spcBef>
             </a:pPr>
             <a:r>
-              <a:rPr sz="1400" b="1" i="0">
+              <a:rPr sz="1400" b="1" i="0" dirty="0">
                 <a:solidFill>
                   <a:srgbClr val="2196F3"/>
                 </a:solidFill>
@@ -6546,7 +6737,7 @@
           </a:p>
           <a:p>
             <a:pPr algn="l"/>
-            <a:endParaRPr sz="1400" b="1" i="0">
+            <a:endParaRPr sz="1400" b="1" i="0" dirty="0">
               <a:solidFill>
                 <a:srgbClr val="2196F3"/>
               </a:solidFill>
@@ -6554,7 +6745,7 @@
           </a:p>
           <a:p>
             <a:pPr algn="l"/>
-            <a:endParaRPr sz="1400" b="1" i="0">
+            <a:endParaRPr sz="1400" b="1" i="0" dirty="0">
               <a:solidFill>
                 <a:srgbClr val="2196F3"/>
               </a:solidFill>
@@ -6563,7 +6754,7 @@
           <a:p>
             <a:pPr algn="ctr"/>
             <a:r>
-              <a:rPr sz="1600" b="1" i="0">
+              <a:rPr sz="1600" b="1" i="0" dirty="0">
                 <a:solidFill>
                   <a:srgbClr val="2196F3"/>
                 </a:solidFill>
@@ -6678,12 +6869,12 @@
           <a:noFill/>
         </p:spPr>
         <p:txBody>
-          <a:bodyPr wrap="square"/>
+          <a:bodyPr wrap="square" anchor="ctr"/>
           <a:lstStyle/>
           <a:p>
             <a:pPr algn="ctr"/>
             <a:r>
-              <a:rPr sz="1300" b="1" i="0">
+              <a:rPr sz="1300" b="1" i="0" dirty="0">
                 <a:solidFill>
                   <a:srgbClr val="FFFFFF"/>
                 </a:solidFill>
@@ -6906,7 +7097,7 @@
           <a:noFill/>
         </p:spPr>
         <p:txBody>
-          <a:bodyPr wrap="square"/>
+          <a:bodyPr wrap="square" anchor="ctr"/>
           <a:lstStyle/>
           <a:p>
             <a:pPr algn="ctr"/>
@@ -7134,7 +7325,7 @@
           <a:noFill/>
         </p:spPr>
         <p:txBody>
-          <a:bodyPr wrap="square"/>
+          <a:bodyPr wrap="square" anchor="ctr"/>
           <a:lstStyle/>
           <a:p>
             <a:pPr algn="ctr"/>
@@ -7309,7 +7500,7 @@
         </p:nvSpPr>
         <p:spPr>
           <a:xfrm>
-            <a:off x="457200" y="4672060"/>
+            <a:off x="411480" y="4527780"/>
             <a:ext cx="8229600" cy="14240"/>
           </a:xfrm>
           <a:prstGeom prst="rect">
@@ -7323,12 +7514,28 @@
           <a:p>
             <a:pPr algn="l"/>
             <a:r>
-              <a:rPr sz="1000" b="0" i="0">
+              <a:rPr sz="1000" b="0" i="0" dirty="0">
                 <a:solidFill>
                   <a:srgbClr val="1A2B3C"/>
                 </a:solidFill>
               </a:rPr>
-              <a:t>Key observations:  T3 (dipping) showed the largest gain (+20.5 pp) — likely benefiting from the pitch contour visualisation.  T4 declined (−7.7 pp) — possibly harder Form B stimuli or high variance with only 3 items per tone.  Caution: n=13, 3 items/tone = limited statistical power.</a:t>
+              <a:t>Key observations:  T3 (dipping) showed the largest gain (+20.5 pp) — likely benefiting from the pitch contour visuali</a:t>
+            </a:r>
+            <a:r>
+              <a:rPr lang="en-US" sz="1000" b="0" i="0" dirty="0">
+                <a:solidFill>
+                  <a:srgbClr val="1A2B3C"/>
+                </a:solidFill>
+              </a:rPr>
+              <a:t>z</a:t>
+            </a:r>
+            <a:r>
+              <a:rPr sz="1000" b="0" i="0" dirty="0">
+                <a:solidFill>
+                  <a:srgbClr val="1A2B3C"/>
+                </a:solidFill>
+              </a:rPr>
+              <a:t>ation.  T4 declined (−7.7 pp) — possibly harder Form B stimuli or high variance with only 3 items per tone.  Caution: n=13, 3 items/tone = limited statistical power.</a:t>
             </a:r>
           </a:p>
         </p:txBody>
@@ -7419,17 +7626,17 @@
           <a:noFill/>
         </p:spPr>
         <p:txBody>
-          <a:bodyPr wrap="square"/>
-          <a:lstStyle/>
-          <a:p>
-            <a:pPr algn="l"/>
-            <a:r>
-              <a:rPr sz="2000" b="1" i="0">
+          <a:bodyPr wrap="square" anchor="ctr"/>
+          <a:lstStyle/>
+          <a:p>
+            <a:pPr algn="l"/>
+            <a:r>
+              <a:rPr sz="2600" b="1" i="0" dirty="0">
                 <a:solidFill>
                   <a:srgbClr val="FFFFFF"/>
                 </a:solidFill>
               </a:rPr>
-              <a:t>App Feedback  —  TAM Usability Survey  (n = 16,  1–5 Likert scale)</a:t>
+              <a:t>App Feedback</a:t>
             </a:r>
           </a:p>
         </p:txBody>
@@ -7619,7 +7826,7 @@
         <p:spPr>
           <a:xfrm>
             <a:off x="5614416" y="2011680"/>
-            <a:ext cx="380000" cy="440000"/>
+            <a:ext cx="471440" cy="440000"/>
           </a:xfrm>
           <a:prstGeom prst="rect">
             <a:avLst/>
@@ -7662,8 +7869,8 @@
         </p:nvSpPr>
         <p:spPr>
           <a:xfrm>
-            <a:off x="5614416" y="2103120"/>
-            <a:ext cx="380000" cy="257120"/>
+            <a:off x="5584165" y="2111490"/>
+            <a:ext cx="531942" cy="257120"/>
           </a:xfrm>
           <a:prstGeom prst="rect">
             <a:avLst/>
@@ -7676,7 +7883,7 @@
           <a:p>
             <a:pPr algn="ctr"/>
             <a:r>
-              <a:rPr sz="1400" b="1" i="0">
+              <a:rPr sz="1400" b="1" i="0" dirty="0">
                 <a:solidFill>
                   <a:srgbClr val="FFFFFF"/>
                 </a:solidFill>
@@ -7708,7 +7915,7 @@
           <a:p>
             <a:pPr algn="l"/>
             <a:r>
-              <a:rPr sz="900" b="0" i="0">
+              <a:rPr sz="900" b="0" i="0" dirty="0">
                 <a:solidFill>
                   <a:srgbClr val="1A2B3C"/>
                 </a:solidFill>
@@ -7771,7 +7978,7 @@
         <p:spPr>
           <a:xfrm>
             <a:off x="5614416" y="2511680"/>
-            <a:ext cx="380000" cy="440000"/>
+            <a:ext cx="471440" cy="440000"/>
           </a:xfrm>
           <a:prstGeom prst="rect">
             <a:avLst/>
@@ -7814,8 +8021,8 @@
         </p:nvSpPr>
         <p:spPr>
           <a:xfrm>
-            <a:off x="5614416" y="2603120"/>
-            <a:ext cx="380000" cy="257120"/>
+            <a:off x="5584165" y="2611490"/>
+            <a:ext cx="531942" cy="257120"/>
           </a:xfrm>
           <a:prstGeom prst="rect">
             <a:avLst/>
@@ -7828,7 +8035,7 @@
           <a:p>
             <a:pPr algn="ctr"/>
             <a:r>
-              <a:rPr sz="1400" b="1" i="0">
+              <a:rPr sz="1400" b="1" i="0" dirty="0">
                 <a:solidFill>
                   <a:srgbClr val="FFFFFF"/>
                 </a:solidFill>
@@ -7923,7 +8130,7 @@
         <p:spPr>
           <a:xfrm>
             <a:off x="5614416" y="3011680"/>
-            <a:ext cx="380000" cy="440000"/>
+            <a:ext cx="471440" cy="440000"/>
           </a:xfrm>
           <a:prstGeom prst="rect">
             <a:avLst/>
@@ -7966,8 +8173,8 @@
         </p:nvSpPr>
         <p:spPr>
           <a:xfrm>
-            <a:off x="5614416" y="3103120"/>
-            <a:ext cx="380000" cy="257120"/>
+            <a:off x="5584165" y="3111490"/>
+            <a:ext cx="531942" cy="257120"/>
           </a:xfrm>
           <a:prstGeom prst="rect">
             <a:avLst/>
@@ -7980,7 +8187,7 @@
           <a:p>
             <a:pPr algn="ctr"/>
             <a:r>
-              <a:rPr sz="1400" b="1" i="0">
+              <a:rPr sz="1400" b="1" i="0" dirty="0">
                 <a:solidFill>
                   <a:srgbClr val="FFFFFF"/>
                 </a:solidFill>
@@ -8075,7 +8282,7 @@
         <p:spPr>
           <a:xfrm>
             <a:off x="5614416" y="3511680"/>
-            <a:ext cx="380000" cy="440000"/>
+            <a:ext cx="471440" cy="440000"/>
           </a:xfrm>
           <a:prstGeom prst="rect">
             <a:avLst/>
@@ -8118,8 +8325,8 @@
         </p:nvSpPr>
         <p:spPr>
           <a:xfrm>
-            <a:off x="5614416" y="3603120"/>
-            <a:ext cx="380000" cy="257120"/>
+            <a:off x="5584165" y="3603120"/>
+            <a:ext cx="531942" cy="257120"/>
           </a:xfrm>
           <a:prstGeom prst="rect">
             <a:avLst/>
@@ -8227,7 +8434,7 @@
         <p:spPr>
           <a:xfrm>
             <a:off x="5614416" y="4011680"/>
-            <a:ext cx="380000" cy="440000"/>
+            <a:ext cx="471440" cy="440000"/>
           </a:xfrm>
           <a:prstGeom prst="rect">
             <a:avLst/>
@@ -8270,8 +8477,8 @@
         </p:nvSpPr>
         <p:spPr>
           <a:xfrm>
-            <a:off x="5614416" y="4103120"/>
-            <a:ext cx="380000" cy="257120"/>
+            <a:off x="5584165" y="4103120"/>
+            <a:ext cx="531942" cy="257120"/>
           </a:xfrm>
           <a:prstGeom prst="rect">
             <a:avLst/>
@@ -8284,7 +8491,7 @@
           <a:p>
             <a:pPr algn="ctr"/>
             <a:r>
-              <a:rPr sz="1400" b="1" i="0">
+              <a:rPr sz="1400" b="1" i="0" dirty="0">
                 <a:solidFill>
                   <a:srgbClr val="FFFFFF"/>
                 </a:solidFill>
@@ -8444,12 +8651,12 @@
           <a:noFill/>
         </p:spPr>
         <p:txBody>
-          <a:bodyPr wrap="square"/>
-          <a:lstStyle/>
-          <a:p>
-            <a:pPr algn="l"/>
-            <a:r>
-              <a:rPr sz="2000" b="1" i="0">
+          <a:bodyPr wrap="square" anchor="ctr"/>
+          <a:lstStyle/>
+          <a:p>
+            <a:pPr algn="l"/>
+            <a:r>
+              <a:rPr sz="2600" b="1" i="0" dirty="0">
                 <a:solidFill>
                   <a:srgbClr val="FFFFFF"/>
                 </a:solidFill>
@@ -8564,7 +8771,7 @@
           <a:noFill/>
         </p:spPr>
         <p:txBody>
-          <a:bodyPr wrap="square"/>
+          <a:bodyPr wrap="square" anchor="ctr"/>
           <a:lstStyle/>
           <a:p>
             <a:pPr algn="ctr"/>
@@ -8610,7 +8817,23 @@
                   <a:srgbClr val="CADCFC"/>
                 </a:solidFill>
               </a:rPr>
-              <a:t>•  Positive pre→post trend (+10.3 pp) across all non-native participants</a:t>
+              <a:t>•  Positive </a:t>
+            </a:r>
+            <a:r>
+              <a:rPr sz="1000" b="0" i="0" dirty="0" err="1">
+                <a:solidFill>
+                  <a:srgbClr val="CADCFC"/>
+                </a:solidFill>
+              </a:rPr>
+              <a:t>pre→post</a:t>
+            </a:r>
+            <a:r>
+              <a:rPr sz="1000" b="0" i="0" dirty="0">
+                <a:solidFill>
+                  <a:srgbClr val="CADCFC"/>
+                </a:solidFill>
+              </a:rPr>
+              <a:t> trend (+10.3 pp) across all non-native participants</a:t>
             </a:r>
           </a:p>
           <a:p>
@@ -8620,7 +8843,7 @@
               </a:spcBef>
             </a:pPr>
             <a:r>
-              <a:rPr sz="1000" b="0" i="0">
+              <a:rPr sz="1000" b="0" i="0" dirty="0">
                 <a:solidFill>
                   <a:srgbClr val="CADCFC"/>
                 </a:solidFill>
@@ -8635,7 +8858,7 @@
               </a:spcBef>
             </a:pPr>
             <a:r>
-              <a:rPr sz="1000" b="0" i="0">
+              <a:rPr sz="1000" b="0" i="0" dirty="0">
                 <a:solidFill>
                   <a:srgbClr val="CADCFC"/>
                 </a:solidFill>
@@ -8650,7 +8873,7 @@
               </a:spcBef>
             </a:pPr>
             <a:r>
-              <a:rPr sz="1000" b="0" i="0">
+              <a:rPr sz="1000" b="0" i="0" dirty="0">
                 <a:solidFill>
                   <a:srgbClr val="CADCFC"/>
                 </a:solidFill>
@@ -8665,7 +8888,7 @@
               </a:spcBef>
             </a:pPr>
             <a:r>
-              <a:rPr sz="1000" b="0" i="0">
+              <a:rPr sz="1000" b="0" i="0" dirty="0">
                 <a:solidFill>
                   <a:srgbClr val="CADCFC"/>
                 </a:solidFill>
@@ -8780,7 +9003,7 @@
           <a:noFill/>
         </p:spPr>
         <p:txBody>
-          <a:bodyPr wrap="square"/>
+          <a:bodyPr wrap="square" anchor="ctr"/>
           <a:lstStyle/>
           <a:p>
             <a:pPr algn="ctr"/>
@@ -8996,7 +9219,7 @@
           <a:noFill/>
         </p:spPr>
         <p:txBody>
-          <a:bodyPr wrap="square"/>
+          <a:bodyPr wrap="square" anchor="ctr"/>
           <a:lstStyle/>
           <a:p>
             <a:pPr algn="ctr"/>
@@ -9159,7 +9382,7 @@
         </p:nvSpPr>
         <p:spPr>
           <a:xfrm>
-            <a:off x="548640" y="4943500"/>
+            <a:off x="548640" y="4840133"/>
             <a:ext cx="8046720" cy="0"/>
           </a:xfrm>
           <a:prstGeom prst="rect">
@@ -9173,7 +9396,7 @@
           <a:p>
             <a:pPr algn="l"/>
             <a:r>
-              <a:rPr sz="1000" b="0" i="1">
+              <a:rPr sz="1000" b="0" i="1" dirty="0">
                 <a:solidFill>
                   <a:srgbClr val="02C39A"/>
                 </a:solidFill>
@@ -9269,12 +9492,12 @@
           <a:noFill/>
         </p:spPr>
         <p:txBody>
-          <a:bodyPr wrap="square"/>
-          <a:lstStyle/>
-          <a:p>
-            <a:pPr algn="l"/>
-            <a:r>
-              <a:rPr sz="2000" b="1" i="0">
+          <a:bodyPr wrap="square" anchor="ctr"/>
+          <a:lstStyle/>
+          <a:p>
+            <a:pPr algn="l"/>
+            <a:r>
+              <a:rPr sz="2600" b="1" i="0" dirty="0">
                 <a:solidFill>
                   <a:srgbClr val="FFFFFF"/>
                 </a:solidFill>
@@ -9389,7 +9612,7 @@
           <a:noFill/>
         </p:spPr>
         <p:txBody>
-          <a:bodyPr wrap="square"/>
+          <a:bodyPr wrap="square" anchor="ctr"/>
           <a:lstStyle/>
           <a:p>
             <a:pPr algn="l"/>
@@ -9590,7 +9813,7 @@
           <a:noFill/>
         </p:spPr>
         <p:txBody>
-          <a:bodyPr wrap="square"/>
+          <a:bodyPr wrap="square" anchor="ctr"/>
           <a:lstStyle/>
           <a:p>
             <a:pPr algn="l"/>
@@ -9791,7 +10014,7 @@
           <a:noFill/>
         </p:spPr>
         <p:txBody>
-          <a:bodyPr wrap="square"/>
+          <a:bodyPr wrap="square" anchor="ctr"/>
           <a:lstStyle/>
           <a:p>
             <a:pPr algn="l"/>
@@ -9883,82 +10106,6 @@
                 </a:solidFill>
               </a:rPr>
               <a:t>✓  Optional: add target-word audio examples to the app</a:t>
-            </a:r>
-          </a:p>
-        </p:txBody>
-      </p:sp>
-      <p:sp>
-        <p:nvSpPr>
-          <p:cNvPr id="16" name="Rectangle 15"/>
-          <p:cNvSpPr/>
-          <p:nvPr/>
-        </p:nvSpPr>
-        <p:spPr>
-          <a:xfrm>
-            <a:off x="274320" y="4672060"/>
-            <a:ext cx="8595360" cy="380000"/>
-          </a:xfrm>
-          <a:prstGeom prst="rect">
-            <a:avLst/>
-          </a:prstGeom>
-          <a:solidFill>
-            <a:srgbClr val="065A82"/>
-          </a:solidFill>
-          <a:ln>
-            <a:noFill/>
-          </a:ln>
-        </p:spPr>
-        <p:style>
-          <a:lnRef idx="1">
-            <a:schemeClr val="accent1"/>
-          </a:lnRef>
-          <a:fillRef idx="3">
-            <a:schemeClr val="accent1"/>
-          </a:fillRef>
-          <a:effectRef idx="2">
-            <a:schemeClr val="accent1"/>
-          </a:effectRef>
-          <a:fontRef idx="minor">
-            <a:schemeClr val="lt1"/>
-          </a:fontRef>
-        </p:style>
-        <p:txBody>
-          <a:bodyPr rtlCol="0" anchor="ctr"/>
-          <a:lstStyle/>
-          <a:p>
-            <a:pPr algn="ctr"/>
-            <a:endParaRPr/>
-          </a:p>
-        </p:txBody>
-      </p:sp>
-      <p:sp>
-        <p:nvSpPr>
-          <p:cNvPr id="17" name="TextBox 16"/>
-          <p:cNvSpPr txBox="1"/>
-          <p:nvPr/>
-        </p:nvSpPr>
-        <p:spPr>
-          <a:xfrm>
-            <a:off x="457200" y="4854940"/>
-            <a:ext cx="8229600" cy="14240"/>
-          </a:xfrm>
-          <a:prstGeom prst="rect">
-            <a:avLst/>
-          </a:prstGeom>
-          <a:noFill/>
-        </p:spPr>
-        <p:txBody>
-          <a:bodyPr wrap="square"/>
-          <a:lstStyle/>
-          <a:p>
-            <a:pPr algn="ctr"/>
-            <a:r>
-              <a:rPr sz="1100" b="1" i="0">
-                <a:solidFill>
-                  <a:srgbClr val="02C39A"/>
-                </a:solidFill>
-              </a:rPr>
-              <a:t>Weeks 8–13 complete  ·  Evaluation done  ·  19 perception test · 16 TAM survey  ·  Data collected  ·  Analysis scripts ready</a:t>
             </a:r>
           </a:p>
         </p:txBody>
@@ -10289,4 +10436,319 @@
   </a:objectDefaults>
   <a:extraClrSchemeLst/>
 </a:theme>
+</file>
+
+<file path=ppt/theme/theme2.xml><?xml version="1.0" encoding="utf-8"?>
+<a:theme xmlns:a="http://schemas.openxmlformats.org/drawingml/2006/main" name="Office Theme">
+  <a:themeElements>
+    <a:clrScheme name="Office">
+      <a:dk1>
+        <a:sysClr val="windowText" lastClr="000000"/>
+      </a:dk1>
+      <a:lt1>
+        <a:sysClr val="window" lastClr="FFFFFF"/>
+      </a:lt1>
+      <a:dk2>
+        <a:srgbClr val="0E2841"/>
+      </a:dk2>
+      <a:lt2>
+        <a:srgbClr val="E8E8E8"/>
+      </a:lt2>
+      <a:accent1>
+        <a:srgbClr val="156082"/>
+      </a:accent1>
+      <a:accent2>
+        <a:srgbClr val="E97132"/>
+      </a:accent2>
+      <a:accent3>
+        <a:srgbClr val="196B24"/>
+      </a:accent3>
+      <a:accent4>
+        <a:srgbClr val="0F9ED5"/>
+      </a:accent4>
+      <a:accent5>
+        <a:srgbClr val="A02B93"/>
+      </a:accent5>
+      <a:accent6>
+        <a:srgbClr val="4EA72E"/>
+      </a:accent6>
+      <a:hlink>
+        <a:srgbClr val="467886"/>
+      </a:hlink>
+      <a:folHlink>
+        <a:srgbClr val="96607D"/>
+      </a:folHlink>
+    </a:clrScheme>
+    <a:fontScheme name="Office">
+      <a:majorFont>
+        <a:latin typeface="Aptos Display" panose="02110004020202020204"/>
+        <a:ea typeface=""/>
+        <a:cs typeface=""/>
+        <a:font script="Jpan" typeface="游ゴシック Light"/>
+        <a:font script="Hang" typeface="맑은 고딕"/>
+        <a:font script="Hans" typeface="等线 Light"/>
+        <a:font script="Hant" typeface="新細明體"/>
+        <a:font script="Arab" typeface="Times New Roman"/>
+        <a:font script="Hebr" typeface="Times New Roman"/>
+        <a:font script="Thai" typeface="Angsana New"/>
+        <a:font script="Ethi" typeface="Nyala"/>
+        <a:font script="Beng" typeface="Vrinda"/>
+        <a:font script="Gujr" typeface="Shruti"/>
+        <a:font script="Khmr" typeface="MoolBoran"/>
+        <a:font script="Knda" typeface="Tunga"/>
+        <a:font script="Guru" typeface="Raavi"/>
+        <a:font script="Cans" typeface="Euphemia"/>
+        <a:font script="Cher" typeface="Plantagenet Cherokee"/>
+        <a:font script="Yiii" typeface="Microsoft Yi Baiti"/>
+        <a:font script="Tibt" typeface="Microsoft Himalaya"/>
+        <a:font script="Thaa" typeface="MV Boli"/>
+        <a:font script="Deva" typeface="Mangal"/>
+        <a:font script="Telu" typeface="Gautami"/>
+        <a:font script="Taml" typeface="Latha"/>
+        <a:font script="Syrc" typeface="Estrangelo Edessa"/>
+        <a:font script="Orya" typeface="Kalinga"/>
+        <a:font script="Mlym" typeface="Kartika"/>
+        <a:font script="Laoo" typeface="DokChampa"/>
+        <a:font script="Sinh" typeface="Iskoola Pota"/>
+        <a:font script="Mong" typeface="Mongolian Baiti"/>
+        <a:font script="Viet" typeface="Times New Roman"/>
+        <a:font script="Uigh" typeface="Microsoft Uighur"/>
+        <a:font script="Geor" typeface="Sylfaen"/>
+        <a:font script="Armn" typeface="Arial"/>
+        <a:font script="Bugi" typeface="Leelawadee UI"/>
+        <a:font script="Bopo" typeface="Microsoft JhengHei"/>
+        <a:font script="Java" typeface="Javanese Text"/>
+        <a:font script="Lisu" typeface="Segoe UI"/>
+        <a:font script="Mymr" typeface="Myanmar Text"/>
+        <a:font script="Nkoo" typeface="Ebrima"/>
+        <a:font script="Olck" typeface="Nirmala UI"/>
+        <a:font script="Osma" typeface="Ebrima"/>
+        <a:font script="Phag" typeface="Phagspa"/>
+        <a:font script="Syrn" typeface="Estrangelo Edessa"/>
+        <a:font script="Syrj" typeface="Estrangelo Edessa"/>
+        <a:font script="Syre" typeface="Estrangelo Edessa"/>
+        <a:font script="Sora" typeface="Nirmala UI"/>
+        <a:font script="Tale" typeface="Microsoft Tai Le"/>
+        <a:font script="Talu" typeface="Microsoft New Tai Lue"/>
+        <a:font script="Tfng" typeface="Ebrima"/>
+      </a:majorFont>
+      <a:minorFont>
+        <a:latin typeface="Aptos" panose="02110004020202020204"/>
+        <a:ea typeface=""/>
+        <a:cs typeface=""/>
+        <a:font script="Jpan" typeface="游ゴシック"/>
+        <a:font script="Hang" typeface="맑은 고딕"/>
+        <a:font script="Hans" typeface="等线"/>
+        <a:font script="Hant" typeface="新細明體"/>
+        <a:font script="Arab" typeface="Arial"/>
+        <a:font script="Hebr" typeface="Arial"/>
+        <a:font script="Thai" typeface="Cordia New"/>
+        <a:font script="Ethi" typeface="Nyala"/>
+        <a:font script="Beng" typeface="Vrinda"/>
+        <a:font script="Gujr" typeface="Shruti"/>
+        <a:font script="Khmr" typeface="DaunPenh"/>
+        <a:font script="Knda" typeface="Tunga"/>
+        <a:font script="Guru" typeface="Raavi"/>
+        <a:font script="Cans" typeface="Euphemia"/>
+        <a:font script="Cher" typeface="Plantagenet Cherokee"/>
+        <a:font script="Yiii" typeface="Microsoft Yi Baiti"/>
+        <a:font script="Tibt" typeface="Microsoft Himalaya"/>
+        <a:font script="Thaa" typeface="MV Boli"/>
+        <a:font script="Deva" typeface="Mangal"/>
+        <a:font script="Telu" typeface="Gautami"/>
+        <a:font script="Taml" typeface="Latha"/>
+        <a:font script="Syrc" typeface="Estrangelo Edessa"/>
+        <a:font script="Orya" typeface="Kalinga"/>
+        <a:font script="Mlym" typeface="Kartika"/>
+        <a:font script="Laoo" typeface="DokChampa"/>
+        <a:font script="Sinh" typeface="Iskoola Pota"/>
+        <a:font script="Mong" typeface="Mongolian Baiti"/>
+        <a:font script="Viet" typeface="Arial"/>
+        <a:font script="Uigh" typeface="Microsoft Uighur"/>
+        <a:font script="Geor" typeface="Sylfaen"/>
+        <a:font script="Armn" typeface="Arial"/>
+        <a:font script="Bugi" typeface="Leelawadee UI"/>
+        <a:font script="Bopo" typeface="Microsoft JhengHei"/>
+        <a:font script="Java" typeface="Javanese Text"/>
+        <a:font script="Lisu" typeface="Segoe UI"/>
+        <a:font script="Mymr" typeface="Myanmar Text"/>
+        <a:font script="Nkoo" typeface="Ebrima"/>
+        <a:font script="Olck" typeface="Nirmala UI"/>
+        <a:font script="Osma" typeface="Ebrima"/>
+        <a:font script="Phag" typeface="Phagspa"/>
+        <a:font script="Syrn" typeface="Estrangelo Edessa"/>
+        <a:font script="Syrj" typeface="Estrangelo Edessa"/>
+        <a:font script="Syre" typeface="Estrangelo Edessa"/>
+        <a:font script="Sora" typeface="Nirmala UI"/>
+        <a:font script="Tale" typeface="Microsoft Tai Le"/>
+        <a:font script="Talu" typeface="Microsoft New Tai Lue"/>
+        <a:font script="Tfng" typeface="Ebrima"/>
+      </a:minorFont>
+    </a:fontScheme>
+    <a:fmtScheme name="Office">
+      <a:fillStyleLst>
+        <a:solidFill>
+          <a:schemeClr val="phClr"/>
+        </a:solidFill>
+        <a:gradFill rotWithShape="1">
+          <a:gsLst>
+            <a:gs pos="0">
+              <a:schemeClr val="phClr">
+                <a:lumMod val="110000"/>
+                <a:satMod val="105000"/>
+                <a:tint val="67000"/>
+              </a:schemeClr>
+            </a:gs>
+            <a:gs pos="50000">
+              <a:schemeClr val="phClr">
+                <a:lumMod val="105000"/>
+                <a:satMod val="103000"/>
+                <a:tint val="73000"/>
+              </a:schemeClr>
+            </a:gs>
+            <a:gs pos="100000">
+              <a:schemeClr val="phClr">
+                <a:lumMod val="105000"/>
+                <a:satMod val="109000"/>
+                <a:tint val="81000"/>
+              </a:schemeClr>
+            </a:gs>
+          </a:gsLst>
+          <a:lin ang="5400000" scaled="0"/>
+        </a:gradFill>
+        <a:gradFill rotWithShape="1">
+          <a:gsLst>
+            <a:gs pos="0">
+              <a:schemeClr val="phClr">
+                <a:satMod val="103000"/>
+                <a:lumMod val="102000"/>
+                <a:tint val="94000"/>
+              </a:schemeClr>
+            </a:gs>
+            <a:gs pos="50000">
+              <a:schemeClr val="phClr">
+                <a:satMod val="110000"/>
+                <a:lumMod val="100000"/>
+                <a:shade val="100000"/>
+              </a:schemeClr>
+            </a:gs>
+            <a:gs pos="100000">
+              <a:schemeClr val="phClr">
+                <a:lumMod val="99000"/>
+                <a:satMod val="120000"/>
+                <a:shade val="78000"/>
+              </a:schemeClr>
+            </a:gs>
+          </a:gsLst>
+          <a:lin ang="5400000" scaled="0"/>
+        </a:gradFill>
+      </a:fillStyleLst>
+      <a:lnStyleLst>
+        <a:ln w="12700" cap="flat" cmpd="sng" algn="ctr">
+          <a:solidFill>
+            <a:schemeClr val="phClr"/>
+          </a:solidFill>
+          <a:prstDash val="solid"/>
+          <a:miter lim="800000"/>
+        </a:ln>
+        <a:ln w="19050" cap="flat" cmpd="sng" algn="ctr">
+          <a:solidFill>
+            <a:schemeClr val="phClr"/>
+          </a:solidFill>
+          <a:prstDash val="solid"/>
+          <a:miter lim="800000"/>
+        </a:ln>
+        <a:ln w="25400" cap="flat" cmpd="sng" algn="ctr">
+          <a:solidFill>
+            <a:schemeClr val="phClr"/>
+          </a:solidFill>
+          <a:prstDash val="solid"/>
+          <a:miter lim="800000"/>
+        </a:ln>
+      </a:lnStyleLst>
+      <a:effectStyleLst>
+        <a:effectStyle>
+          <a:effectLst/>
+        </a:effectStyle>
+        <a:effectStyle>
+          <a:effectLst/>
+        </a:effectStyle>
+        <a:effectStyle>
+          <a:effectLst>
+            <a:outerShdw blurRad="57150" dist="19050" dir="5400000" algn="ctr" rotWithShape="0">
+              <a:srgbClr val="000000">
+                <a:alpha val="63000"/>
+              </a:srgbClr>
+            </a:outerShdw>
+          </a:effectLst>
+        </a:effectStyle>
+      </a:effectStyleLst>
+      <a:bgFillStyleLst>
+        <a:solidFill>
+          <a:schemeClr val="phClr"/>
+        </a:solidFill>
+        <a:solidFill>
+          <a:schemeClr val="phClr">
+            <a:tint val="95000"/>
+            <a:satMod val="170000"/>
+          </a:schemeClr>
+        </a:solidFill>
+        <a:gradFill rotWithShape="1">
+          <a:gsLst>
+            <a:gs pos="0">
+              <a:schemeClr val="phClr">
+                <a:tint val="93000"/>
+                <a:satMod val="150000"/>
+                <a:shade val="98000"/>
+                <a:lumMod val="102000"/>
+              </a:schemeClr>
+            </a:gs>
+            <a:gs pos="50000">
+              <a:schemeClr val="phClr">
+                <a:tint val="98000"/>
+                <a:satMod val="130000"/>
+                <a:shade val="90000"/>
+                <a:lumMod val="103000"/>
+              </a:schemeClr>
+            </a:gs>
+            <a:gs pos="100000">
+              <a:schemeClr val="phClr">
+                <a:shade val="63000"/>
+                <a:satMod val="120000"/>
+              </a:schemeClr>
+            </a:gs>
+          </a:gsLst>
+          <a:lin ang="5400000" scaled="0"/>
+        </a:gradFill>
+      </a:bgFillStyleLst>
+    </a:fmtScheme>
+  </a:themeElements>
+  <a:objectDefaults>
+    <a:lnDef>
+      <a:spPr/>
+      <a:bodyPr/>
+      <a:lstStyle/>
+      <a:style>
+        <a:lnRef idx="2">
+          <a:schemeClr val="accent1"/>
+        </a:lnRef>
+        <a:fillRef idx="0">
+          <a:schemeClr val="accent1"/>
+        </a:fillRef>
+        <a:effectRef idx="1">
+          <a:schemeClr val="accent1"/>
+        </a:effectRef>
+        <a:fontRef idx="minor">
+          <a:schemeClr val="tx1"/>
+        </a:fontRef>
+      </a:style>
+    </a:lnDef>
+  </a:objectDefaults>
+  <a:extraClrSchemeLst/>
+  <a:extLst>
+    <a:ext uri="{05A4C25C-085E-4340-85A3-A5531E510DB2}">
+      <thm15:themeFamily xmlns:thm15="http://schemas.microsoft.com/office/thememl/2012/main" name="Office Theme" id="{2E142A2C-CD16-42D6-873A-C26D2A0506FA}" vid="{1BDDFF52-6CD6-40A5-AB3C-68EB2F1E4D0A}"/>
+    </a:ext>
+  </a:extLst>
+</a:theme>
 </file>
</xml_diff>